<commit_message>
Added demo video for powerpoint
</commit_message>
<xml_diff>
--- a/Documentation/Weekly Report/week11/CMSC-4920-Week11-Group2.pptx
+++ b/Documentation/Weekly Report/week11/CMSC-4920-Week11-Group2.pptx
@@ -5,7 +5,7 @@
     <p:sldMasterId id="2147483648" r:id="rId1"/>
   </p:sldMasterIdLst>
   <p:notesMasterIdLst>
-    <p:notesMasterId r:id="rId13"/>
+    <p:notesMasterId r:id="rId14"/>
   </p:notesMasterIdLst>
   <p:sldIdLst>
     <p:sldId id="256" r:id="rId2"/>
@@ -16,9 +16,10 @@
     <p:sldId id="268" r:id="rId7"/>
     <p:sldId id="269" r:id="rId8"/>
     <p:sldId id="267" r:id="rId9"/>
-    <p:sldId id="264" r:id="rId10"/>
-    <p:sldId id="259" r:id="rId11"/>
-    <p:sldId id="260" r:id="rId12"/>
+    <p:sldId id="270" r:id="rId10"/>
+    <p:sldId id="264" r:id="rId11"/>
+    <p:sldId id="259" r:id="rId12"/>
+    <p:sldId id="260" r:id="rId13"/>
   </p:sldIdLst>
   <p:sldSz cx="12192000" cy="6858000"/>
   <p:notesSz cx="6858000" cy="9144000"/>
@@ -129,7 +130,7 @@
 <p1510:revInfo xmlns:a="http://schemas.openxmlformats.org/drawingml/2006/main" xmlns:r="http://schemas.openxmlformats.org/officeDocument/2006/relationships" xmlns:p1510="http://schemas.microsoft.com/office/powerpoint/2015/10/main">
   <p1510:revLst>
     <p1510:client id="{06411FC2-7443-4BF5-B8F4-5EEEE928CA1B}" v="1" dt="2026-03-29T13:00:01.797"/>
-    <p1510:client id="{E4911506-1446-4B59-A2E1-F4B0482CAD7F}" v="4" dt="2026-03-28T15:09:02.563"/>
+    <p1510:client id="{F1153A02-BEDE-4F12-9C85-90E595CEEC5D}" v="1" dt="2026-03-29T18:04:13.323"/>
   </p1510:revLst>
 </p1510:revInfo>
 </file>
@@ -139,7 +140,7 @@
   <pc:docChgLst>
     <pc:chgData name="John Gerega" userId="bd3e1e46fb6a714b" providerId="LiveId" clId="{45F0C402-C550-4C82-B31D-5B32217A5E94}"/>
     <pc:docChg chg="undo custSel addSld delSld modSld">
-      <pc:chgData name="John Gerega" userId="bd3e1e46fb6a714b" providerId="LiveId" clId="{45F0C402-C550-4C82-B31D-5B32217A5E94}" dt="2026-03-29T13:00:56.525" v="2636" actId="20577"/>
+      <pc:chgData name="John Gerega" userId="bd3e1e46fb6a714b" providerId="LiveId" clId="{45F0C402-C550-4C82-B31D-5B32217A5E94}" dt="2026-03-29T18:05:46.299" v="2673" actId="1076"/>
       <pc:docMkLst>
         <pc:docMk/>
       </pc:docMkLst>
@@ -219,6 +220,133 @@
             <ac:spMk id="6" creationId="{3B13CF04-9C06-053E-69E2-58CD31C3D276}"/>
           </ac:spMkLst>
         </pc:spChg>
+      </pc:sldChg>
+      <pc:sldChg chg="addSp delSp modSp new mod setBg modAnim">
+        <pc:chgData name="John Gerega" userId="bd3e1e46fb6a714b" providerId="LiveId" clId="{45F0C402-C550-4C82-B31D-5B32217A5E94}" dt="2026-03-29T18:05:46.299" v="2673" actId="1076"/>
+        <pc:sldMkLst>
+          <pc:docMk/>
+          <pc:sldMk cId="2962377671" sldId="270"/>
+        </pc:sldMkLst>
+        <pc:spChg chg="mod">
+          <ac:chgData name="John Gerega" userId="bd3e1e46fb6a714b" providerId="LiveId" clId="{45F0C402-C550-4C82-B31D-5B32217A5E94}" dt="2026-03-29T18:05:18.557" v="2667" actId="26606"/>
+          <ac:spMkLst>
+            <pc:docMk/>
+            <pc:sldMk cId="2962377671" sldId="270"/>
+            <ac:spMk id="2" creationId="{13C1DCD7-BC43-FECE-2085-88664A263119}"/>
+          </ac:spMkLst>
+        </pc:spChg>
+        <pc:spChg chg="del">
+          <ac:chgData name="John Gerega" userId="bd3e1e46fb6a714b" providerId="LiveId" clId="{45F0C402-C550-4C82-B31D-5B32217A5E94}" dt="2026-03-29T18:04:13.323" v="2648"/>
+          <ac:spMkLst>
+            <pc:docMk/>
+            <pc:sldMk cId="2962377671" sldId="270"/>
+            <ac:spMk id="3" creationId="{B5975AFB-80B2-1811-F7DC-7FB1C9DEFA8B}"/>
+          </ac:spMkLst>
+        </pc:spChg>
+        <pc:spChg chg="add del">
+          <ac:chgData name="John Gerega" userId="bd3e1e46fb6a714b" providerId="LiveId" clId="{45F0C402-C550-4C82-B31D-5B32217A5E94}" dt="2026-03-29T18:04:30.842" v="2650" actId="26606"/>
+          <ac:spMkLst>
+            <pc:docMk/>
+            <pc:sldMk cId="2962377671" sldId="270"/>
+            <ac:spMk id="9" creationId="{D12DDE76-C203-4047-9998-63900085B5E8}"/>
+          </ac:spMkLst>
+        </pc:spChg>
+        <pc:spChg chg="add del">
+          <ac:chgData name="John Gerega" userId="bd3e1e46fb6a714b" providerId="LiveId" clId="{45F0C402-C550-4C82-B31D-5B32217A5E94}" dt="2026-03-29T18:04:44.857" v="2663" actId="26606"/>
+          <ac:spMkLst>
+            <pc:docMk/>
+            <pc:sldMk cId="2962377671" sldId="270"/>
+            <ac:spMk id="14" creationId="{754DFD36-CDEA-4A58-ABEC-DA9CE2CB2697}"/>
+          </ac:spMkLst>
+        </pc:spChg>
+        <pc:spChg chg="add del">
+          <ac:chgData name="John Gerega" userId="bd3e1e46fb6a714b" providerId="LiveId" clId="{45F0C402-C550-4C82-B31D-5B32217A5E94}" dt="2026-03-29T18:05:18.557" v="2667" actId="26606"/>
+          <ac:spMkLst>
+            <pc:docMk/>
+            <pc:sldMk cId="2962377671" sldId="270"/>
+            <ac:spMk id="19" creationId="{A8384FB5-9ADC-4DDC-881B-597D56F5B15D}"/>
+          </ac:spMkLst>
+        </pc:spChg>
+        <pc:spChg chg="add del">
+          <ac:chgData name="John Gerega" userId="bd3e1e46fb6a714b" providerId="LiveId" clId="{45F0C402-C550-4C82-B31D-5B32217A5E94}" dt="2026-03-29T18:05:18.557" v="2667" actId="26606"/>
+          <ac:spMkLst>
+            <pc:docMk/>
+            <pc:sldMk cId="2962377671" sldId="270"/>
+            <ac:spMk id="21" creationId="{91E5A9A7-95C6-4F4F-B00E-C82E07FE62EF}"/>
+          </ac:spMkLst>
+        </pc:spChg>
+        <pc:spChg chg="add del">
+          <ac:chgData name="John Gerega" userId="bd3e1e46fb6a714b" providerId="LiveId" clId="{45F0C402-C550-4C82-B31D-5B32217A5E94}" dt="2026-03-29T18:05:18.557" v="2667" actId="26606"/>
+          <ac:spMkLst>
+            <pc:docMk/>
+            <pc:sldMk cId="2962377671" sldId="270"/>
+            <ac:spMk id="23" creationId="{D07DD2DE-F619-49DD-B5E7-03A290FF4ED1}"/>
+          </ac:spMkLst>
+        </pc:spChg>
+        <pc:spChg chg="add del">
+          <ac:chgData name="John Gerega" userId="bd3e1e46fb6a714b" providerId="LiveId" clId="{45F0C402-C550-4C82-B31D-5B32217A5E94}" dt="2026-03-29T18:05:18.557" v="2667" actId="26606"/>
+          <ac:spMkLst>
+            <pc:docMk/>
+            <pc:sldMk cId="2962377671" sldId="270"/>
+            <ac:spMk id="25" creationId="{85149191-5F60-4A28-AAFF-039F96B0F3EC}"/>
+          </ac:spMkLst>
+        </pc:spChg>
+        <pc:spChg chg="add del">
+          <ac:chgData name="John Gerega" userId="bd3e1e46fb6a714b" providerId="LiveId" clId="{45F0C402-C550-4C82-B31D-5B32217A5E94}" dt="2026-03-29T18:05:18.557" v="2667" actId="26606"/>
+          <ac:spMkLst>
+            <pc:docMk/>
+            <pc:sldMk cId="2962377671" sldId="270"/>
+            <ac:spMk id="27" creationId="{F8260ED5-17F7-4158-B241-D51DD4CF1B7E}"/>
+          </ac:spMkLst>
+        </pc:spChg>
+        <pc:spChg chg="add">
+          <ac:chgData name="John Gerega" userId="bd3e1e46fb6a714b" providerId="LiveId" clId="{45F0C402-C550-4C82-B31D-5B32217A5E94}" dt="2026-03-29T18:05:18.557" v="2667" actId="26606"/>
+          <ac:spMkLst>
+            <pc:docMk/>
+            <pc:sldMk cId="2962377671" sldId="270"/>
+            <ac:spMk id="32" creationId="{A8384FB5-9ADC-4DDC-881B-597D56F5B15D}"/>
+          </ac:spMkLst>
+        </pc:spChg>
+        <pc:spChg chg="add">
+          <ac:chgData name="John Gerega" userId="bd3e1e46fb6a714b" providerId="LiveId" clId="{45F0C402-C550-4C82-B31D-5B32217A5E94}" dt="2026-03-29T18:05:18.557" v="2667" actId="26606"/>
+          <ac:spMkLst>
+            <pc:docMk/>
+            <pc:sldMk cId="2962377671" sldId="270"/>
+            <ac:spMk id="34" creationId="{1199E1B1-A8C0-4FE8-A5A8-1CB41D69F857}"/>
+          </ac:spMkLst>
+        </pc:spChg>
+        <pc:spChg chg="add">
+          <ac:chgData name="John Gerega" userId="bd3e1e46fb6a714b" providerId="LiveId" clId="{45F0C402-C550-4C82-B31D-5B32217A5E94}" dt="2026-03-29T18:05:18.557" v="2667" actId="26606"/>
+          <ac:spMkLst>
+            <pc:docMk/>
+            <pc:sldMk cId="2962377671" sldId="270"/>
+            <ac:spMk id="36" creationId="{84A8DE83-DE75-4B41-9DB4-A7EC0B0DEC0B}"/>
+          </ac:spMkLst>
+        </pc:spChg>
+        <pc:spChg chg="add">
+          <ac:chgData name="John Gerega" userId="bd3e1e46fb6a714b" providerId="LiveId" clId="{45F0C402-C550-4C82-B31D-5B32217A5E94}" dt="2026-03-29T18:05:18.557" v="2667" actId="26606"/>
+          <ac:spMkLst>
+            <pc:docMk/>
+            <pc:sldMk cId="2962377671" sldId="270"/>
+            <ac:spMk id="38" creationId="{A7009A0A-BEF5-4EAC-AF15-E4F9F002E239}"/>
+          </ac:spMkLst>
+        </pc:spChg>
+        <pc:grpChg chg="add del">
+          <ac:chgData name="John Gerega" userId="bd3e1e46fb6a714b" providerId="LiveId" clId="{45F0C402-C550-4C82-B31D-5B32217A5E94}" dt="2026-03-29T18:04:44.857" v="2663" actId="26606"/>
+          <ac:grpSpMkLst>
+            <pc:docMk/>
+            <pc:sldMk cId="2962377671" sldId="270"/>
+            <ac:grpSpMk id="11" creationId="{F938B951-7EFC-40A2-B198-E73D39DFB3FC}"/>
+          </ac:grpSpMkLst>
+        </pc:grpChg>
+        <pc:picChg chg="add mod">
+          <ac:chgData name="John Gerega" userId="bd3e1e46fb6a714b" providerId="LiveId" clId="{45F0C402-C550-4C82-B31D-5B32217A5E94}" dt="2026-03-29T18:05:46.299" v="2673" actId="1076"/>
+          <ac:picMkLst>
+            <pc:docMk/>
+            <pc:sldMk cId="2962377671" sldId="270"/>
+            <ac:picMk id="4" creationId="{4F012FE5-91F7-BF57-0376-41BC4711BDEB}"/>
+          </ac:picMkLst>
+        </pc:picChg>
       </pc:sldChg>
     </pc:docChg>
   </pc:docChgLst>
@@ -10294,6 +10422,358 @@
     </p:bg>
     <p:spTree>
       <p:nvGrpSpPr>
+        <p:cNvPr id="1" name="">
+          <a:extLst>
+            <a:ext uri="{FF2B5EF4-FFF2-40B4-BE49-F238E27FC236}">
+              <a16:creationId xmlns:a16="http://schemas.microsoft.com/office/drawing/2014/main" id="{38138CFD-A501-8AEC-C666-BED845111F6D}"/>
+            </a:ext>
+          </a:extLst>
+        </p:cNvPr>
+        <p:cNvGrpSpPr/>
+        <p:nvPr/>
+      </p:nvGrpSpPr>
+      <p:grpSpPr>
+        <a:xfrm>
+          <a:off x="0" y="0"/>
+          <a:ext cx="0" cy="0"/>
+          <a:chOff x="0" y="0"/>
+          <a:chExt cx="0" cy="0"/>
+        </a:xfrm>
+      </p:grpSpPr>
+      <p:sp useBgFill="1">
+        <p:nvSpPr>
+          <p:cNvPr id="21" name="Rectangle 20">
+            <a:extLst>
+              <a:ext uri="{FF2B5EF4-FFF2-40B4-BE49-F238E27FC236}">
+                <a16:creationId xmlns:a16="http://schemas.microsoft.com/office/drawing/2014/main" id="{356F68EF-088F-20DD-B4B1-6BCF0A8C9BF2}"/>
+              </a:ext>
+              <a:ext uri="{C183D7F6-B498-43B3-948B-1728B52AA6E4}">
+                <adec:decorative xmlns:adec="http://schemas.microsoft.com/office/drawing/2017/decorative" val="1"/>
+              </a:ext>
+            </a:extLst>
+          </p:cNvPr>
+          <p:cNvSpPr>
+            <a:spLocks noGrp="1" noRot="1" noChangeAspect="1" noMove="1" noResize="1" noEditPoints="1" noAdjustHandles="1" noChangeArrowheads="1" noChangeShapeType="1" noTextEdit="1"/>
+          </p:cNvSpPr>
+          <p:nvPr>
+            <p:extLst>
+              <p:ext uri="{386F3935-93C4-4BCD-93E2-E3B085C9AB24}">
+                <p16:designElem xmlns:p16="http://schemas.microsoft.com/office/powerpoint/2015/main" val="1"/>
+              </p:ext>
+            </p:extLst>
+          </p:nvPr>
+        </p:nvSpPr>
+        <p:spPr>
+          <a:xfrm>
+            <a:off x="0" y="0"/>
+            <a:ext cx="12191999" cy="6857365"/>
+          </a:xfrm>
+          <a:prstGeom prst="rect">
+            <a:avLst/>
+          </a:prstGeom>
+          <a:ln>
+            <a:noFill/>
+          </a:ln>
+        </p:spPr>
+        <p:style>
+          <a:lnRef idx="2">
+            <a:schemeClr val="accent1">
+              <a:shade val="50000"/>
+            </a:schemeClr>
+          </a:lnRef>
+          <a:fillRef idx="1">
+            <a:schemeClr val="accent1"/>
+          </a:fillRef>
+          <a:effectRef idx="0">
+            <a:schemeClr val="accent1"/>
+          </a:effectRef>
+          <a:fontRef idx="minor">
+            <a:schemeClr val="lt1"/>
+          </a:fontRef>
+        </p:style>
+        <p:txBody>
+          <a:bodyPr rtlCol="0" anchor="ctr"/>
+          <a:lstStyle/>
+          <a:p>
+            <a:pPr algn="ctr"/>
+            <a:endParaRPr lang="en-US"/>
+          </a:p>
+        </p:txBody>
+      </p:sp>
+      <p:sp>
+        <p:nvSpPr>
+          <p:cNvPr id="22" name="Rectangle 21">
+            <a:extLst>
+              <a:ext uri="{FF2B5EF4-FFF2-40B4-BE49-F238E27FC236}">
+                <a16:creationId xmlns:a16="http://schemas.microsoft.com/office/drawing/2014/main" id="{9EF082FE-D96F-0D2A-34AA-F987D0796D34}"/>
+              </a:ext>
+              <a:ext uri="{C183D7F6-B498-43B3-948B-1728B52AA6E4}">
+                <adec:decorative xmlns:adec="http://schemas.microsoft.com/office/drawing/2017/decorative" val="1"/>
+              </a:ext>
+            </a:extLst>
+          </p:cNvPr>
+          <p:cNvSpPr>
+            <a:spLocks noGrp="1" noRot="1" noChangeAspect="1" noMove="1" noResize="1" noEditPoints="1" noAdjustHandles="1" noChangeArrowheads="1" noChangeShapeType="1" noTextEdit="1"/>
+          </p:cNvSpPr>
+          <p:nvPr>
+            <p:extLst>
+              <p:ext uri="{386F3935-93C4-4BCD-93E2-E3B085C9AB24}">
+                <p16:designElem xmlns:p16="http://schemas.microsoft.com/office/powerpoint/2015/main" val="1"/>
+              </p:ext>
+            </p:extLst>
+          </p:nvPr>
+        </p:nvSpPr>
+        <p:spPr>
+          <a:xfrm>
+            <a:off x="0" y="1"/>
+            <a:ext cx="12192000" cy="5187142"/>
+          </a:xfrm>
+          <a:prstGeom prst="rect">
+            <a:avLst/>
+          </a:prstGeom>
+          <a:solidFill>
+            <a:schemeClr val="accent4"/>
+          </a:solidFill>
+          <a:ln>
+            <a:noFill/>
+          </a:ln>
+        </p:spPr>
+        <p:style>
+          <a:lnRef idx="2">
+            <a:schemeClr val="accent1">
+              <a:shade val="50000"/>
+            </a:schemeClr>
+          </a:lnRef>
+          <a:fillRef idx="1">
+            <a:schemeClr val="accent1"/>
+          </a:fillRef>
+          <a:effectRef idx="0">
+            <a:schemeClr val="accent1"/>
+          </a:effectRef>
+          <a:fontRef idx="minor">
+            <a:schemeClr val="lt1"/>
+          </a:fontRef>
+        </p:style>
+        <p:txBody>
+          <a:bodyPr rtlCol="0" anchor="ctr"/>
+          <a:lstStyle/>
+          <a:p>
+            <a:pPr algn="ctr"/>
+            <a:endParaRPr lang="en-US" dirty="0"/>
+          </a:p>
+        </p:txBody>
+      </p:sp>
+      <p:sp>
+        <p:nvSpPr>
+          <p:cNvPr id="23" name="Rectangle 22">
+            <a:extLst>
+              <a:ext uri="{FF2B5EF4-FFF2-40B4-BE49-F238E27FC236}">
+                <a16:creationId xmlns:a16="http://schemas.microsoft.com/office/drawing/2014/main" id="{0BE13FF0-F6F1-375E-D271-70DAE72E1AC7}"/>
+              </a:ext>
+              <a:ext uri="{C183D7F6-B498-43B3-948B-1728B52AA6E4}">
+                <adec:decorative xmlns:adec="http://schemas.microsoft.com/office/drawing/2017/decorative" val="1"/>
+              </a:ext>
+            </a:extLst>
+          </p:cNvPr>
+          <p:cNvSpPr>
+            <a:spLocks noGrp="1" noRot="1" noChangeAspect="1" noMove="1" noResize="1" noEditPoints="1" noAdjustHandles="1" noChangeArrowheads="1" noChangeShapeType="1" noTextEdit="1"/>
+          </p:cNvSpPr>
+          <p:nvPr>
+            <p:extLst>
+              <p:ext uri="{386F3935-93C4-4BCD-93E2-E3B085C9AB24}">
+                <p16:designElem xmlns:p16="http://schemas.microsoft.com/office/powerpoint/2015/main" val="1"/>
+              </p:ext>
+            </p:extLst>
+          </p:nvPr>
+        </p:nvSpPr>
+        <p:spPr>
+          <a:xfrm>
+            <a:off x="596464" y="551961"/>
+            <a:ext cx="10999072" cy="5399950"/>
+          </a:xfrm>
+          <a:prstGeom prst="rect">
+            <a:avLst/>
+          </a:prstGeom>
+          <a:solidFill>
+            <a:schemeClr val="bg1"/>
+          </a:solidFill>
+          <a:ln>
+            <a:noFill/>
+          </a:ln>
+          <a:effectLst>
+            <a:outerShdw blurRad="139700" dist="127000" dir="5400000" algn="t" rotWithShape="0">
+              <a:prstClr val="black">
+                <a:alpha val="15000"/>
+              </a:prstClr>
+            </a:outerShdw>
+          </a:effectLst>
+        </p:spPr>
+        <p:style>
+          <a:lnRef idx="2">
+            <a:schemeClr val="accent1">
+              <a:shade val="50000"/>
+            </a:schemeClr>
+          </a:lnRef>
+          <a:fillRef idx="1">
+            <a:schemeClr val="accent1"/>
+          </a:fillRef>
+          <a:effectRef idx="0">
+            <a:schemeClr val="accent1"/>
+          </a:effectRef>
+          <a:fontRef idx="minor">
+            <a:schemeClr val="lt1"/>
+          </a:fontRef>
+        </p:style>
+        <p:txBody>
+          <a:bodyPr rtlCol="0" anchor="ctr"/>
+          <a:lstStyle/>
+          <a:p>
+            <a:pPr algn="ctr"/>
+            <a:endParaRPr lang="en-US"/>
+          </a:p>
+        </p:txBody>
+      </p:sp>
+      <p:cxnSp>
+        <p:nvCxnSpPr>
+          <p:cNvPr id="25" name="Straight Connector 24">
+            <a:extLst>
+              <a:ext uri="{FF2B5EF4-FFF2-40B4-BE49-F238E27FC236}">
+                <a16:creationId xmlns:a16="http://schemas.microsoft.com/office/drawing/2014/main" id="{3A7F67B2-22A5-7F2D-13EB-E06229F5CB46}"/>
+              </a:ext>
+              <a:ext uri="{C183D7F6-B498-43B3-948B-1728B52AA6E4}">
+                <adec:decorative xmlns:adec="http://schemas.microsoft.com/office/drawing/2017/decorative" val="1"/>
+              </a:ext>
+            </a:extLst>
+          </p:cNvPr>
+          <p:cNvCxnSpPr>
+            <a:cxnSpLocks noGrp="1" noRot="1" noChangeAspect="1" noMove="1" noResize="1" noEditPoints="1" noAdjustHandles="1" noChangeArrowheads="1" noChangeShapeType="1"/>
+          </p:cNvCxnSpPr>
+          <p:nvPr>
+            <p:extLst>
+              <p:ext uri="{386F3935-93C4-4BCD-93E2-E3B085C9AB24}">
+                <p16:designElem xmlns:p16="http://schemas.microsoft.com/office/powerpoint/2015/main" val="1"/>
+              </p:ext>
+            </p:extLst>
+          </p:nvPr>
+        </p:nvCxnSpPr>
+        <p:spPr>
+          <a:xfrm flipH="1">
+            <a:off x="596464" y="6329769"/>
+            <a:ext cx="11000232" cy="0"/>
+          </a:xfrm>
+          <a:prstGeom prst="line">
+            <a:avLst/>
+          </a:prstGeom>
+          <a:ln w="152400">
+            <a:solidFill>
+              <a:schemeClr val="accent4"/>
+            </a:solidFill>
+          </a:ln>
+        </p:spPr>
+        <p:style>
+          <a:lnRef idx="1">
+            <a:schemeClr val="accent1"/>
+          </a:lnRef>
+          <a:fillRef idx="0">
+            <a:schemeClr val="accent1"/>
+          </a:fillRef>
+          <a:effectRef idx="0">
+            <a:schemeClr val="accent1"/>
+          </a:effectRef>
+          <a:fontRef idx="minor">
+            <a:schemeClr val="tx1"/>
+          </a:fontRef>
+        </p:style>
+      </p:cxnSp>
+      <p:sp>
+        <p:nvSpPr>
+          <p:cNvPr id="9" name="Title 1">
+            <a:extLst>
+              <a:ext uri="{FF2B5EF4-FFF2-40B4-BE49-F238E27FC236}">
+                <a16:creationId xmlns:a16="http://schemas.microsoft.com/office/drawing/2014/main" id="{D6D36DC8-D9BF-8C26-69EA-ED89E34DB644}"/>
+              </a:ext>
+            </a:extLst>
+          </p:cNvPr>
+          <p:cNvSpPr>
+            <a:spLocks noGrp="1"/>
+          </p:cNvSpPr>
+          <p:nvPr>
+            <p:ph type="title"/>
+          </p:nvPr>
+        </p:nvSpPr>
+        <p:spPr>
+          <a:xfrm>
+            <a:off x="4008559" y="768350"/>
+            <a:ext cx="4162181" cy="920920"/>
+          </a:xfrm>
+        </p:spPr>
+        <p:txBody>
+          <a:bodyPr>
+            <a:normAutofit fontScale="90000"/>
+          </a:bodyPr>
+          <a:lstStyle/>
+          <a:p>
+            <a:r>
+              <a:rPr lang="en-US" dirty="0"/>
+              <a:t>Week 12 Plan</a:t>
+            </a:r>
+          </a:p>
+        </p:txBody>
+      </p:sp>
+      <p:graphicFrame>
+        <p:nvGraphicFramePr>
+          <p:cNvPr id="27" name="Text Placeholder 2">
+            <a:extLst>
+              <a:ext uri="{FF2B5EF4-FFF2-40B4-BE49-F238E27FC236}">
+                <a16:creationId xmlns:a16="http://schemas.microsoft.com/office/drawing/2014/main" id="{D6B93F0B-FEB0-EDAB-CFE1-A57DEFE97FCD}"/>
+              </a:ext>
+            </a:extLst>
+          </p:cNvPr>
+          <p:cNvGraphicFramePr/>
+          <p:nvPr>
+            <p:extLst>
+              <p:ext uri="{D42A27DB-BD31-4B8C-83A1-F6EECF244321}">
+                <p14:modId xmlns:p14="http://schemas.microsoft.com/office/powerpoint/2010/main" val="3016178620"/>
+              </p:ext>
+            </p:extLst>
+          </p:nvPr>
+        </p:nvGraphicFramePr>
+        <p:xfrm>
+          <a:off x="838199" y="2688113"/>
+          <a:ext cx="10515600" cy="3050990"/>
+        </p:xfrm>
+        <a:graphic>
+          <a:graphicData uri="http://schemas.openxmlformats.org/drawingml/2006/diagram">
+            <dgm:relIds xmlns:dgm="http://schemas.openxmlformats.org/drawingml/2006/diagram" xmlns:r="http://schemas.openxmlformats.org/officeDocument/2006/relationships" r:dm="rId2" r:lo="rId3" r:qs="rId4" r:cs="rId5"/>
+          </a:graphicData>
+        </a:graphic>
+      </p:graphicFrame>
+    </p:spTree>
+    <p:extLst>
+      <p:ext uri="{BB962C8B-B14F-4D97-AF65-F5344CB8AC3E}">
+        <p14:creationId xmlns:p14="http://schemas.microsoft.com/office/powerpoint/2010/main" val="2561402868"/>
+      </p:ext>
+    </p:extLst>
+  </p:cSld>
+  <p:clrMapOvr>
+    <a:masterClrMapping/>
+  </p:clrMapOvr>
+</p:sld>
+</file>
+
+<file path=ppt/slides/slide11.xml><?xml version="1.0" encoding="utf-8"?>
+<p:sld xmlns:a="http://schemas.openxmlformats.org/drawingml/2006/main" xmlns:r="http://schemas.openxmlformats.org/officeDocument/2006/relationships" xmlns:p="http://schemas.openxmlformats.org/presentationml/2006/main">
+  <p:cSld>
+    <p:bg>
+      <p:bgPr>
+        <a:solidFill>
+          <a:schemeClr val="bg1"/>
+        </a:solidFill>
+        <a:effectLst/>
+      </p:bgPr>
+    </p:bg>
+    <p:spTree>
+      <p:nvGrpSpPr>
         <p:cNvPr id="1" name=""/>
         <p:cNvGrpSpPr/>
         <p:nvPr/>
@@ -10669,7 +11149,7 @@
 </p:sld>
 </file>
 
-<file path=ppt/slides/slide11.xml><?xml version="1.0" encoding="utf-8"?>
+<file path=ppt/slides/slide12.xml><?xml version="1.0" encoding="utf-8"?>
 <p:sld xmlns:a="http://schemas.openxmlformats.org/drawingml/2006/main" xmlns:r="http://schemas.openxmlformats.org/officeDocument/2006/relationships" xmlns:p="http://schemas.openxmlformats.org/presentationml/2006/main">
   <p:cSld>
     <p:bg>
@@ -14116,13 +14596,7 @@
     </p:bg>
     <p:spTree>
       <p:nvGrpSpPr>
-        <p:cNvPr id="1" name="">
-          <a:extLst>
-            <a:ext uri="{FF2B5EF4-FFF2-40B4-BE49-F238E27FC236}">
-              <a16:creationId xmlns:a16="http://schemas.microsoft.com/office/drawing/2014/main" id="{38138CFD-A501-8AEC-C666-BED845111F6D}"/>
-            </a:ext>
-          </a:extLst>
-        </p:cNvPr>
+        <p:cNvPr id="1" name=""/>
         <p:cNvGrpSpPr/>
         <p:nvPr/>
       </p:nvGrpSpPr>
@@ -14136,10 +14610,10 @@
       </p:grpSpPr>
       <p:sp useBgFill="1">
         <p:nvSpPr>
-          <p:cNvPr id="21" name="Rectangle 20">
+          <p:cNvPr id="32" name="Rectangle 31">
             <a:extLst>
               <a:ext uri="{FF2B5EF4-FFF2-40B4-BE49-F238E27FC236}">
-                <a16:creationId xmlns:a16="http://schemas.microsoft.com/office/drawing/2014/main" id="{356F68EF-088F-20DD-B4B1-6BCF0A8C9BF2}"/>
+                <a16:creationId xmlns:a16="http://schemas.microsoft.com/office/drawing/2014/main" id="{A8384FB5-9ADC-4DDC-881B-597D56F5B15D}"/>
               </a:ext>
               <a:ext uri="{C183D7F6-B498-43B3-948B-1728B52AA6E4}">
                 <adec:decorative xmlns:adec="http://schemas.microsoft.com/office/drawing/2017/decorative" val="1"/>
@@ -14160,11 +14634,102 @@
         <p:spPr>
           <a:xfrm>
             <a:off x="0" y="0"/>
-            <a:ext cx="12191999" cy="6857365"/>
+            <a:ext cx="12192000" cy="6858000"/>
           </a:xfrm>
           <a:prstGeom prst="rect">
             <a:avLst/>
           </a:prstGeom>
+          <a:ln w="12700" cap="flat" cmpd="sng" algn="ctr">
+            <a:noFill/>
+            <a:prstDash val="solid"/>
+            <a:miter lim="800000"/>
+          </a:ln>
+          <a:effectLst/>
+          <a:extLst>
+            <a:ext uri="{91240B29-F687-4F45-9708-019B960494DF}">
+              <a14:hiddenLine xmlns:a14="http://schemas.microsoft.com/office/drawing/2010/main" w="12700" cap="flat" cmpd="sng" algn="ctr">
+                <a:solidFill>
+                  <a:schemeClr val="accent1">
+                    <a:shade val="50000"/>
+                  </a:schemeClr>
+                </a:solidFill>
+                <a:prstDash val="solid"/>
+                <a:miter lim="800000"/>
+              </a14:hiddenLine>
+            </a:ext>
+          </a:extLst>
+        </p:spPr>
+        <p:style>
+          <a:lnRef idx="2">
+            <a:schemeClr val="accent1">
+              <a:shade val="50000"/>
+            </a:schemeClr>
+          </a:lnRef>
+          <a:fillRef idx="1">
+            <a:schemeClr val="accent1"/>
+          </a:fillRef>
+          <a:effectRef idx="0">
+            <a:schemeClr val="accent1"/>
+          </a:effectRef>
+          <a:fontRef idx="minor">
+            <a:schemeClr val="lt1"/>
+          </a:fontRef>
+        </p:style>
+        <p:txBody>
+          <a:bodyPr rtlCol="0" anchor="ctr"/>
+          <a:lstStyle/>
+          <a:p>
+            <a:pPr algn="ctr"/>
+            <a:endParaRPr lang="en-US"/>
+          </a:p>
+        </p:txBody>
+      </p:sp>
+      <p:sp>
+        <p:nvSpPr>
+          <p:cNvPr id="34" name="Rectangle 33">
+            <a:extLst>
+              <a:ext uri="{FF2B5EF4-FFF2-40B4-BE49-F238E27FC236}">
+                <a16:creationId xmlns:a16="http://schemas.microsoft.com/office/drawing/2014/main" id="{1199E1B1-A8C0-4FE8-A5A8-1CB41D69F857}"/>
+              </a:ext>
+              <a:ext uri="{C183D7F6-B498-43B3-948B-1728B52AA6E4}">
+                <adec:decorative xmlns:adec="http://schemas.microsoft.com/office/drawing/2017/decorative" val="1"/>
+              </a:ext>
+            </a:extLst>
+          </p:cNvPr>
+          <p:cNvSpPr>
+            <a:spLocks noGrp="1" noRot="1" noChangeAspect="1" noMove="1" noResize="1" noEditPoints="1" noAdjustHandles="1" noChangeArrowheads="1" noChangeShapeType="1" noTextEdit="1"/>
+          </p:cNvSpPr>
+          <p:nvPr>
+            <p:extLst>
+              <p:ext uri="{386F3935-93C4-4BCD-93E2-E3B085C9AB24}">
+                <p16:designElem xmlns:p16="http://schemas.microsoft.com/office/powerpoint/2015/main" val="1"/>
+              </p:ext>
+            </p:extLst>
+          </p:nvPr>
+        </p:nvSpPr>
+        <p:spPr>
+          <a:xfrm rot="10800000" flipH="1">
+            <a:off x="2" y="0"/>
+            <a:ext cx="12191998" cy="1575955"/>
+          </a:xfrm>
+          <a:prstGeom prst="rect">
+            <a:avLst/>
+          </a:prstGeom>
+          <a:gradFill>
+            <a:gsLst>
+              <a:gs pos="0">
+                <a:srgbClr val="000000">
+                  <a:alpha val="96000"/>
+                </a:srgbClr>
+              </a:gs>
+              <a:gs pos="100000">
+                <a:schemeClr val="accent1">
+                  <a:lumMod val="75000"/>
+                </a:schemeClr>
+              </a:gs>
+            </a:gsLst>
+            <a:lin ang="6000000" scaled="0"/>
+          </a:gradFill>
           <a:ln>
             <a:noFill/>
           </a:ln>
@@ -14196,10 +14761,10 @@
       </p:sp>
       <p:sp>
         <p:nvSpPr>
-          <p:cNvPr id="22" name="Rectangle 21">
+          <p:cNvPr id="36" name="Rectangle 35">
             <a:extLst>
               <a:ext uri="{FF2B5EF4-FFF2-40B4-BE49-F238E27FC236}">
-                <a16:creationId xmlns:a16="http://schemas.microsoft.com/office/drawing/2014/main" id="{9EF082FE-D96F-0D2A-34AA-F987D0796D34}"/>
+                <a16:creationId xmlns:a16="http://schemas.microsoft.com/office/drawing/2014/main" id="{84A8DE83-DE75-4B41-9DB4-A7EC0B0DEC0B}"/>
               </a:ext>
               <a:ext uri="{C183D7F6-B498-43B3-948B-1728B52AA6E4}">
                 <adec:decorative xmlns:adec="http://schemas.microsoft.com/office/drawing/2017/decorative" val="1"/>
@@ -14219,15 +14784,29 @@
         </p:nvSpPr>
         <p:spPr>
           <a:xfrm>
-            <a:off x="0" y="1"/>
-            <a:ext cx="12192000" cy="5187142"/>
+            <a:off x="0" y="0"/>
+            <a:ext cx="8128856" cy="1575461"/>
           </a:xfrm>
           <a:prstGeom prst="rect">
             <a:avLst/>
           </a:prstGeom>
-          <a:solidFill>
-            <a:schemeClr val="accent4"/>
-          </a:solidFill>
+          <a:gradFill>
+            <a:gsLst>
+              <a:gs pos="0">
+                <a:schemeClr val="accent1">
+                  <a:alpha val="41000"/>
+                </a:schemeClr>
+              </a:gs>
+              <a:gs pos="74000">
+                <a:schemeClr val="accent1">
+                  <a:lumMod val="60000"/>
+                  <a:lumOff val="40000"/>
+                  <a:alpha val="0"/>
+                </a:schemeClr>
+              </a:gs>
+            </a:gsLst>
+            <a:lin ang="8400000" scaled="0"/>
+          </a:gradFill>
           <a:ln>
             <a:noFill/>
           </a:ln>
@@ -14253,16 +14832,16 @@
           <a:lstStyle/>
           <a:p>
             <a:pPr algn="ctr"/>
-            <a:endParaRPr lang="en-US" dirty="0"/>
+            <a:endParaRPr lang="en-US"/>
           </a:p>
         </p:txBody>
       </p:sp>
       <p:sp>
         <p:nvSpPr>
-          <p:cNvPr id="23" name="Rectangle 22">
+          <p:cNvPr id="38" name="Rectangle 37">
             <a:extLst>
               <a:ext uri="{FF2B5EF4-FFF2-40B4-BE49-F238E27FC236}">
-                <a16:creationId xmlns:a16="http://schemas.microsoft.com/office/drawing/2014/main" id="{0BE13FF0-F6F1-375E-D271-70DAE72E1AC7}"/>
+                <a16:creationId xmlns:a16="http://schemas.microsoft.com/office/drawing/2014/main" id="{A7009A0A-BEF5-4EAC-AF15-E4F9F002E239}"/>
               </a:ext>
               <a:ext uri="{C183D7F6-B498-43B3-948B-1728B52AA6E4}">
                 <adec:decorative xmlns:adec="http://schemas.microsoft.com/office/drawing/2017/decorative" val="1"/>
@@ -14281,26 +14860,31 @@
           </p:nvPr>
         </p:nvSpPr>
         <p:spPr>
-          <a:xfrm>
-            <a:off x="596464" y="551961"/>
-            <a:ext cx="10999072" cy="5399950"/>
+          <a:xfrm flipH="1">
+            <a:off x="-3" y="-1"/>
+            <a:ext cx="12192002" cy="1574311"/>
           </a:xfrm>
           <a:prstGeom prst="rect">
             <a:avLst/>
           </a:prstGeom>
-          <a:solidFill>
-            <a:schemeClr val="bg1"/>
-          </a:solidFill>
+          <a:gradFill>
+            <a:gsLst>
+              <a:gs pos="0">
+                <a:srgbClr val="000000">
+                  <a:alpha val="63000"/>
+                </a:srgbClr>
+              </a:gs>
+              <a:gs pos="78000">
+                <a:schemeClr val="accent1">
+                  <a:alpha val="15000"/>
+                </a:schemeClr>
+              </a:gs>
+            </a:gsLst>
+            <a:lin ang="15600000" scaled="0"/>
+          </a:gradFill>
           <a:ln>
             <a:noFill/>
           </a:ln>
-          <a:effectLst>
-            <a:outerShdw blurRad="139700" dist="127000" dir="5400000" algn="t" rotWithShape="0">
-              <a:prstClr val="black">
-                <a:alpha val="15000"/>
-              </a:prstClr>
-            </a:outerShdw>
-          </a:effectLst>
         </p:spPr>
         <p:style>
           <a:lnRef idx="2">
@@ -14327,64 +14911,12 @@
           </a:p>
         </p:txBody>
       </p:sp>
-      <p:cxnSp>
-        <p:nvCxnSpPr>
-          <p:cNvPr id="25" name="Straight Connector 24">
+      <p:sp>
+        <p:nvSpPr>
+          <p:cNvPr id="2" name="Title 1">
             <a:extLst>
               <a:ext uri="{FF2B5EF4-FFF2-40B4-BE49-F238E27FC236}">
-                <a16:creationId xmlns:a16="http://schemas.microsoft.com/office/drawing/2014/main" id="{3A7F67B2-22A5-7F2D-13EB-E06229F5CB46}"/>
-              </a:ext>
-              <a:ext uri="{C183D7F6-B498-43B3-948B-1728B52AA6E4}">
-                <adec:decorative xmlns:adec="http://schemas.microsoft.com/office/drawing/2017/decorative" val="1"/>
-              </a:ext>
-            </a:extLst>
-          </p:cNvPr>
-          <p:cNvCxnSpPr>
-            <a:cxnSpLocks noGrp="1" noRot="1" noChangeAspect="1" noMove="1" noResize="1" noEditPoints="1" noAdjustHandles="1" noChangeArrowheads="1" noChangeShapeType="1"/>
-          </p:cNvCxnSpPr>
-          <p:nvPr>
-            <p:extLst>
-              <p:ext uri="{386F3935-93C4-4BCD-93E2-E3B085C9AB24}">
-                <p16:designElem xmlns:p16="http://schemas.microsoft.com/office/powerpoint/2015/main" val="1"/>
-              </p:ext>
-            </p:extLst>
-          </p:nvPr>
-        </p:nvCxnSpPr>
-        <p:spPr>
-          <a:xfrm flipH="1">
-            <a:off x="596464" y="6329769"/>
-            <a:ext cx="11000232" cy="0"/>
-          </a:xfrm>
-          <a:prstGeom prst="line">
-            <a:avLst/>
-          </a:prstGeom>
-          <a:ln w="152400">
-            <a:solidFill>
-              <a:schemeClr val="accent4"/>
-            </a:solidFill>
-          </a:ln>
-        </p:spPr>
-        <p:style>
-          <a:lnRef idx="1">
-            <a:schemeClr val="accent1"/>
-          </a:lnRef>
-          <a:fillRef idx="0">
-            <a:schemeClr val="accent1"/>
-          </a:fillRef>
-          <a:effectRef idx="0">
-            <a:schemeClr val="accent1"/>
-          </a:effectRef>
-          <a:fontRef idx="minor">
-            <a:schemeClr val="tx1"/>
-          </a:fontRef>
-        </p:style>
-      </p:cxnSp>
-      <p:sp>
-        <p:nvSpPr>
-          <p:cNvPr id="9" name="Title 1">
-            <a:extLst>
-              <a:ext uri="{FF2B5EF4-FFF2-40B4-BE49-F238E27FC236}">
-                <a16:creationId xmlns:a16="http://schemas.microsoft.com/office/drawing/2014/main" id="{D6D36DC8-D9BF-8C26-69EA-ED89E34DB644}"/>
+                <a16:creationId xmlns:a16="http://schemas.microsoft.com/office/drawing/2014/main" id="{13C1DCD7-BC43-FECE-2085-88664A263119}"/>
               </a:ext>
             </a:extLst>
           </p:cNvPr>
@@ -14397,61 +14929,214 @@
         </p:nvSpPr>
         <p:spPr>
           <a:xfrm>
-            <a:off x="4008559" y="768350"/>
-            <a:ext cx="4162181" cy="920920"/>
+            <a:off x="699713" y="248038"/>
+            <a:ext cx="7063721" cy="1159200"/>
           </a:xfrm>
         </p:spPr>
         <p:txBody>
-          <a:bodyPr>
-            <a:normAutofit fontScale="90000"/>
+          <a:bodyPr vert="horz" lIns="91440" tIns="45720" rIns="91440" bIns="45720" rtlCol="0" anchor="ctr">
+            <a:normAutofit/>
           </a:bodyPr>
           <a:lstStyle/>
           <a:p>
             <a:r>
-              <a:rPr lang="en-US" dirty="0"/>
-              <a:t>Week 12 Plan</a:t>
+              <a:rPr lang="en-US" sz="4000" kern="1200">
+                <a:solidFill>
+                  <a:srgbClr val="FFFFFF"/>
+                </a:solidFill>
+                <a:latin typeface="+mj-lt"/>
+                <a:ea typeface="+mj-ea"/>
+                <a:cs typeface="+mj-cs"/>
+              </a:rPr>
+              <a:t>Teams Page Progress</a:t>
             </a:r>
           </a:p>
         </p:txBody>
       </p:sp>
-      <p:graphicFrame>
-        <p:nvGraphicFramePr>
-          <p:cNvPr id="27" name="Text Placeholder 2">
+      <p:pic>
+        <p:nvPicPr>
+          <p:cNvPr id="4" name="TeamsPageCoach">
+            <a:hlinkClick r:id="" action="ppaction://media"/>
             <a:extLst>
               <a:ext uri="{FF2B5EF4-FFF2-40B4-BE49-F238E27FC236}">
-                <a16:creationId xmlns:a16="http://schemas.microsoft.com/office/drawing/2014/main" id="{D6B93F0B-FEB0-EDAB-CFE1-A57DEFE97FCD}"/>
+                <a16:creationId xmlns:a16="http://schemas.microsoft.com/office/drawing/2014/main" id="{4F012FE5-91F7-BF57-0376-41BC4711BDEB}"/>
               </a:ext>
             </a:extLst>
           </p:cNvPr>
-          <p:cNvGraphicFramePr/>
+          <p:cNvPicPr>
+            <a:picLocks noGrp="1" noChangeAspect="1"/>
+          </p:cNvPicPr>
           <p:nvPr>
+            <p:ph idx="1"/>
+            <a:videoFile r:link="rId2"/>
             <p:extLst>
-              <p:ext uri="{D42A27DB-BD31-4B8C-83A1-F6EECF244321}">
-                <p14:modId xmlns:p14="http://schemas.microsoft.com/office/powerpoint/2010/main" val="3016178620"/>
+              <p:ext uri="{DAA4B4D4-6D71-4841-9C94-3DE7FCFB9230}">
+                <p14:media xmlns:p14="http://schemas.microsoft.com/office/powerpoint/2010/main" r:embed="rId1"/>
               </p:ext>
             </p:extLst>
           </p:nvPr>
-        </p:nvGraphicFramePr>
-        <p:xfrm>
-          <a:off x="838199" y="2688113"/>
-          <a:ext cx="10515600" cy="3050990"/>
-        </p:xfrm>
-        <a:graphic>
-          <a:graphicData uri="http://schemas.openxmlformats.org/drawingml/2006/diagram">
-            <dgm:relIds xmlns:dgm="http://schemas.openxmlformats.org/drawingml/2006/diagram" xmlns:r="http://schemas.openxmlformats.org/officeDocument/2006/relationships" r:dm="rId2" r:lo="rId3" r:qs="rId4" r:cs="rId5"/>
-          </a:graphicData>
-        </a:graphic>
-      </p:graphicFrame>
+        </p:nvPicPr>
+        <p:blipFill>
+          <a:blip r:embed="rId4"/>
+          <a:stretch>
+            <a:fillRect/>
+          </a:stretch>
+        </p:blipFill>
+        <p:spPr>
+          <a:xfrm>
+            <a:off x="-4" y="1574310"/>
+            <a:ext cx="12191998" cy="5367226"/>
+          </a:xfrm>
+          <a:prstGeom prst="rect">
+            <a:avLst/>
+          </a:prstGeom>
+        </p:spPr>
+      </p:pic>
     </p:spTree>
     <p:extLst>
       <p:ext uri="{BB962C8B-B14F-4D97-AF65-F5344CB8AC3E}">
-        <p14:creationId xmlns:p14="http://schemas.microsoft.com/office/powerpoint/2010/main" val="2561402868"/>
+        <p14:creationId xmlns:p14="http://schemas.microsoft.com/office/powerpoint/2010/main" val="2962377671"/>
       </p:ext>
     </p:extLst>
   </p:cSld>
   <p:clrMapOvr>
     <a:masterClrMapping/>
   </p:clrMapOvr>
+  <p:timing>
+    <p:tnLst>
+      <p:par>
+        <p:cTn id="1" dur="indefinite" restart="never" nodeType="tmRoot">
+          <p:childTnLst>
+            <p:seq concurrent="1" nextAc="seek">
+              <p:cTn id="2" dur="indefinite" nodeType="mainSeq">
+                <p:childTnLst>
+                  <p:par>
+                    <p:cTn id="3" fill="hold">
+                      <p:stCondLst>
+                        <p:cond delay="indefinite"/>
+                      </p:stCondLst>
+                      <p:childTnLst>
+                        <p:par>
+                          <p:cTn id="4" fill="hold">
+                            <p:stCondLst>
+                              <p:cond delay="0"/>
+                            </p:stCondLst>
+                            <p:childTnLst>
+                              <p:par>
+                                <p:cTn id="5" presetID="1" presetClass="mediacall" presetSubtype="0" fill="hold" nodeType="clickEffect">
+                                  <p:stCondLst>
+                                    <p:cond delay="0"/>
+                                  </p:stCondLst>
+                                  <p:childTnLst>
+                                    <p:cmd type="call" cmd="playFrom(0.0)">
+                                      <p:cBhvr>
+                                        <p:cTn id="6" dur="70890" fill="hold"/>
+                                        <p:tgtEl>
+                                          <p:spTgt spid="4"/>
+                                        </p:tgtEl>
+                                      </p:cBhvr>
+                                    </p:cmd>
+                                  </p:childTnLst>
+                                </p:cTn>
+                              </p:par>
+                            </p:childTnLst>
+                          </p:cTn>
+                        </p:par>
+                      </p:childTnLst>
+                    </p:cTn>
+                  </p:par>
+                </p:childTnLst>
+              </p:cTn>
+              <p:prevCondLst>
+                <p:cond evt="onPrev" delay="0">
+                  <p:tgtEl>
+                    <p:sldTgt/>
+                  </p:tgtEl>
+                </p:cond>
+              </p:prevCondLst>
+              <p:nextCondLst>
+                <p:cond evt="onNext" delay="0">
+                  <p:tgtEl>
+                    <p:sldTgt/>
+                  </p:tgtEl>
+                </p:cond>
+              </p:nextCondLst>
+            </p:seq>
+            <p:video>
+              <p:cMediaNode vol="80000">
+                <p:cTn id="7" fill="hold" display="0">
+                  <p:stCondLst>
+                    <p:cond delay="indefinite"/>
+                  </p:stCondLst>
+                </p:cTn>
+                <p:tgtEl>
+                  <p:spTgt spid="4"/>
+                </p:tgtEl>
+              </p:cMediaNode>
+            </p:video>
+            <p:seq concurrent="1" nextAc="seek">
+              <p:cTn id="8" restart="whenNotActive" fill="hold" evtFilter="cancelBubble" nodeType="interactiveSeq">
+                <p:stCondLst>
+                  <p:cond evt="onClick" delay="0">
+                    <p:tgtEl>
+                      <p:spTgt spid="4"/>
+                    </p:tgtEl>
+                  </p:cond>
+                </p:stCondLst>
+                <p:endSync evt="end" delay="0">
+                  <p:rtn val="all"/>
+                </p:endSync>
+                <p:childTnLst>
+                  <p:par>
+                    <p:cTn id="9" fill="hold">
+                      <p:stCondLst>
+                        <p:cond delay="0"/>
+                      </p:stCondLst>
+                      <p:childTnLst>
+                        <p:par>
+                          <p:cTn id="10" fill="hold">
+                            <p:stCondLst>
+                              <p:cond delay="0"/>
+                            </p:stCondLst>
+                            <p:childTnLst>
+                              <p:par>
+                                <p:cTn id="11" presetID="2" presetClass="mediacall" presetSubtype="0" fill="hold" nodeType="clickEffect">
+                                  <p:stCondLst>
+                                    <p:cond delay="0"/>
+                                  </p:stCondLst>
+                                  <p:childTnLst>
+                                    <p:cmd type="call" cmd="togglePause">
+                                      <p:cBhvr>
+                                        <p:cTn id="12" dur="1" fill="hold"/>
+                                        <p:tgtEl>
+                                          <p:spTgt spid="4"/>
+                                        </p:tgtEl>
+                                      </p:cBhvr>
+                                    </p:cmd>
+                                  </p:childTnLst>
+                                </p:cTn>
+                              </p:par>
+                            </p:childTnLst>
+                          </p:cTn>
+                        </p:par>
+                      </p:childTnLst>
+                    </p:cTn>
+                  </p:par>
+                </p:childTnLst>
+              </p:cTn>
+              <p:nextCondLst>
+                <p:cond evt="onClick" delay="0">
+                  <p:tgtEl>
+                    <p:spTgt spid="4"/>
+                  </p:tgtEl>
+                </p:cond>
+              </p:nextCondLst>
+            </p:seq>
+          </p:childTnLst>
+        </p:cTn>
+      </p:par>
+    </p:tnLst>
+  </p:timing>
 </p:sld>
 </file>
 

</xml_diff>

<commit_message>
added to docs and updated website
</commit_message>
<xml_diff>
--- a/Documentation/Weekly Report/week11/CMSC-4920-Week11-Group2.pptx
+++ b/Documentation/Weekly Report/week11/CMSC-4920-Week11-Group2.pptx
@@ -5,7 +5,7 @@
     <p:sldMasterId id="2147483648" r:id="rId1"/>
   </p:sldMasterIdLst>
   <p:notesMasterIdLst>
-    <p:notesMasterId r:id="rId13"/>
+    <p:notesMasterId r:id="rId15"/>
   </p:notesMasterIdLst>
   <p:sldIdLst>
     <p:sldId id="256" r:id="rId2"/>
@@ -16,9 +16,11 @@
     <p:sldId id="268" r:id="rId7"/>
     <p:sldId id="269" r:id="rId8"/>
     <p:sldId id="267" r:id="rId9"/>
-    <p:sldId id="264" r:id="rId10"/>
-    <p:sldId id="259" r:id="rId11"/>
-    <p:sldId id="260" r:id="rId12"/>
+    <p:sldId id="270" r:id="rId10"/>
+    <p:sldId id="271" r:id="rId11"/>
+    <p:sldId id="264" r:id="rId12"/>
+    <p:sldId id="259" r:id="rId13"/>
+    <p:sldId id="260" r:id="rId14"/>
   </p:sldIdLst>
   <p:sldSz cx="12192000" cy="6858000"/>
   <p:notesSz cx="6858000" cy="9144000"/>
@@ -137,6 +139,68 @@
 <file path=ppt/changesInfos/changesInfo1.xml><?xml version="1.0" encoding="utf-8"?>
 <pc:chgInfo xmlns:a="http://schemas.openxmlformats.org/drawingml/2006/main" xmlns:r="http://schemas.openxmlformats.org/officeDocument/2006/relationships" xmlns:ac="http://schemas.microsoft.com/office/drawing/2013/main/command" xmlns:pc="http://schemas.microsoft.com/office/powerpoint/2013/main/command">
   <pc:docChgLst>
+    <pc:chgData name="Margo Bonal" userId="18c9fa0f-b53d-478b-9dc0-6ad88786c19f" providerId="ADAL" clId="{93D479E5-F67F-4B8A-A78F-A0B574A116B6}"/>
+    <pc:docChg chg="undo custSel addSld delSld modSld">
+      <pc:chgData name="Margo Bonal" userId="18c9fa0f-b53d-478b-9dc0-6ad88786c19f" providerId="ADAL" clId="{93D479E5-F67F-4B8A-A78F-A0B574A116B6}" dt="2026-03-21T14:21:56.751" v="935" actId="27636"/>
+      <pc:docMkLst>
+        <pc:docMk/>
+      </pc:docMkLst>
+      <pc:sldChg chg="modSp mod">
+        <pc:chgData name="Margo Bonal" userId="18c9fa0f-b53d-478b-9dc0-6ad88786c19f" providerId="ADAL" clId="{93D479E5-F67F-4B8A-A78F-A0B574A116B6}" dt="2026-03-21T14:21:56.751" v="935" actId="27636"/>
+        <pc:sldMkLst>
+          <pc:docMk/>
+          <pc:sldMk cId="2561402868" sldId="264"/>
+        </pc:sldMkLst>
+        <pc:spChg chg="mod">
+          <ac:chgData name="Margo Bonal" userId="18c9fa0f-b53d-478b-9dc0-6ad88786c19f" providerId="ADAL" clId="{93D479E5-F67F-4B8A-A78F-A0B574A116B6}" dt="2026-03-21T14:21:56.751" v="935" actId="27636"/>
+          <ac:spMkLst>
+            <pc:docMk/>
+            <pc:sldMk cId="2561402868" sldId="264"/>
+            <ac:spMk id="9" creationId="{D6D36DC8-D9BF-8C26-69EA-ED89E34DB644}"/>
+          </ac:spMkLst>
+        </pc:spChg>
+        <pc:graphicFrameChg chg="mod modGraphic">
+          <ac:chgData name="Margo Bonal" userId="18c9fa0f-b53d-478b-9dc0-6ad88786c19f" providerId="ADAL" clId="{93D479E5-F67F-4B8A-A78F-A0B574A116B6}" dt="2026-03-21T14:21:54.477" v="931" actId="20577"/>
+          <ac:graphicFrameMkLst>
+            <pc:docMk/>
+            <pc:sldMk cId="2561402868" sldId="264"/>
+            <ac:graphicFrameMk id="27" creationId="{D6B93F0B-FEB0-EDAB-CFE1-A57DEFE97FCD}"/>
+          </ac:graphicFrameMkLst>
+        </pc:graphicFrameChg>
+      </pc:sldChg>
+      <pc:sldChg chg="delSp modSp mod">
+        <pc:chgData name="Margo Bonal" userId="18c9fa0f-b53d-478b-9dc0-6ad88786c19f" providerId="ADAL" clId="{93D479E5-F67F-4B8A-A78F-A0B574A116B6}" dt="2026-03-21T14:09:41.161" v="486"/>
+        <pc:sldMkLst>
+          <pc:docMk/>
+          <pc:sldMk cId="2428741132" sldId="265"/>
+        </pc:sldMkLst>
+      </pc:sldChg>
+      <pc:sldChg chg="modSp mod">
+        <pc:chgData name="Margo Bonal" userId="18c9fa0f-b53d-478b-9dc0-6ad88786c19f" providerId="ADAL" clId="{93D479E5-F67F-4B8A-A78F-A0B574A116B6}" dt="2026-03-21T14:09:48.188" v="518" actId="20577"/>
+        <pc:sldMkLst>
+          <pc:docMk/>
+          <pc:sldMk cId="3526335932" sldId="266"/>
+        </pc:sldMkLst>
+        <pc:spChg chg="mod">
+          <ac:chgData name="Margo Bonal" userId="18c9fa0f-b53d-478b-9dc0-6ad88786c19f" providerId="ADAL" clId="{93D479E5-F67F-4B8A-A78F-A0B574A116B6}" dt="2026-03-21T14:09:48.188" v="518" actId="20577"/>
+          <ac:spMkLst>
+            <pc:docMk/>
+            <pc:sldMk cId="3526335932" sldId="266"/>
+            <ac:spMk id="3" creationId="{CCDEAB36-867D-95B6-8834-F42C5B9259D0}"/>
+          </ac:spMkLst>
+        </pc:spChg>
+        <pc:spChg chg="mod">
+          <ac:chgData name="Margo Bonal" userId="18c9fa0f-b53d-478b-9dc0-6ad88786c19f" providerId="ADAL" clId="{93D479E5-F67F-4B8A-A78F-A0B574A116B6}" dt="2026-03-21T14:09:45.490" v="517" actId="20577"/>
+          <ac:spMkLst>
+            <pc:docMk/>
+            <pc:sldMk cId="3526335932" sldId="266"/>
+            <ac:spMk id="4" creationId="{86ED9EE4-56A8-6AFD-BE9A-A35D2ABC59A0}"/>
+          </ac:spMkLst>
+        </pc:spChg>
+      </pc:sldChg>
+    </pc:docChg>
+  </pc:docChgLst>
+  <pc:docChgLst>
     <pc:chgData name="John Gerega" userId="bd3e1e46fb6a714b" providerId="LiveId" clId="{45F0C402-C550-4C82-B31D-5B32217A5E94}"/>
     <pc:docChg chg="undo custSel addSld delSld modSld">
       <pc:chgData name="John Gerega" userId="bd3e1e46fb6a714b" providerId="LiveId" clId="{45F0C402-C550-4C82-B31D-5B32217A5E94}" dt="2026-03-29T13:00:56.525" v="2636" actId="20577"/>
@@ -217,68 +281,6 @@
             <pc:docMk/>
             <pc:sldMk cId="3526335932" sldId="266"/>
             <ac:spMk id="6" creationId="{3B13CF04-9C06-053E-69E2-58CD31C3D276}"/>
-          </ac:spMkLst>
-        </pc:spChg>
-      </pc:sldChg>
-    </pc:docChg>
-  </pc:docChgLst>
-  <pc:docChgLst>
-    <pc:chgData name="Margo Bonal" userId="18c9fa0f-b53d-478b-9dc0-6ad88786c19f" providerId="ADAL" clId="{93D479E5-F67F-4B8A-A78F-A0B574A116B6}"/>
-    <pc:docChg chg="undo custSel addSld delSld modSld">
-      <pc:chgData name="Margo Bonal" userId="18c9fa0f-b53d-478b-9dc0-6ad88786c19f" providerId="ADAL" clId="{93D479E5-F67F-4B8A-A78F-A0B574A116B6}" dt="2026-03-21T14:21:56.751" v="935" actId="27636"/>
-      <pc:docMkLst>
-        <pc:docMk/>
-      </pc:docMkLst>
-      <pc:sldChg chg="modSp mod">
-        <pc:chgData name="Margo Bonal" userId="18c9fa0f-b53d-478b-9dc0-6ad88786c19f" providerId="ADAL" clId="{93D479E5-F67F-4B8A-A78F-A0B574A116B6}" dt="2026-03-21T14:21:56.751" v="935" actId="27636"/>
-        <pc:sldMkLst>
-          <pc:docMk/>
-          <pc:sldMk cId="2561402868" sldId="264"/>
-        </pc:sldMkLst>
-        <pc:spChg chg="mod">
-          <ac:chgData name="Margo Bonal" userId="18c9fa0f-b53d-478b-9dc0-6ad88786c19f" providerId="ADAL" clId="{93D479E5-F67F-4B8A-A78F-A0B574A116B6}" dt="2026-03-21T14:21:56.751" v="935" actId="27636"/>
-          <ac:spMkLst>
-            <pc:docMk/>
-            <pc:sldMk cId="2561402868" sldId="264"/>
-            <ac:spMk id="9" creationId="{D6D36DC8-D9BF-8C26-69EA-ED89E34DB644}"/>
-          </ac:spMkLst>
-        </pc:spChg>
-        <pc:graphicFrameChg chg="mod modGraphic">
-          <ac:chgData name="Margo Bonal" userId="18c9fa0f-b53d-478b-9dc0-6ad88786c19f" providerId="ADAL" clId="{93D479E5-F67F-4B8A-A78F-A0B574A116B6}" dt="2026-03-21T14:21:54.477" v="931" actId="20577"/>
-          <ac:graphicFrameMkLst>
-            <pc:docMk/>
-            <pc:sldMk cId="2561402868" sldId="264"/>
-            <ac:graphicFrameMk id="27" creationId="{D6B93F0B-FEB0-EDAB-CFE1-A57DEFE97FCD}"/>
-          </ac:graphicFrameMkLst>
-        </pc:graphicFrameChg>
-      </pc:sldChg>
-      <pc:sldChg chg="delSp modSp mod">
-        <pc:chgData name="Margo Bonal" userId="18c9fa0f-b53d-478b-9dc0-6ad88786c19f" providerId="ADAL" clId="{93D479E5-F67F-4B8A-A78F-A0B574A116B6}" dt="2026-03-21T14:09:41.161" v="486"/>
-        <pc:sldMkLst>
-          <pc:docMk/>
-          <pc:sldMk cId="2428741132" sldId="265"/>
-        </pc:sldMkLst>
-      </pc:sldChg>
-      <pc:sldChg chg="modSp mod">
-        <pc:chgData name="Margo Bonal" userId="18c9fa0f-b53d-478b-9dc0-6ad88786c19f" providerId="ADAL" clId="{93D479E5-F67F-4B8A-A78F-A0B574A116B6}" dt="2026-03-21T14:09:48.188" v="518" actId="20577"/>
-        <pc:sldMkLst>
-          <pc:docMk/>
-          <pc:sldMk cId="3526335932" sldId="266"/>
-        </pc:sldMkLst>
-        <pc:spChg chg="mod">
-          <ac:chgData name="Margo Bonal" userId="18c9fa0f-b53d-478b-9dc0-6ad88786c19f" providerId="ADAL" clId="{93D479E5-F67F-4B8A-A78F-A0B574A116B6}" dt="2026-03-21T14:09:48.188" v="518" actId="20577"/>
-          <ac:spMkLst>
-            <pc:docMk/>
-            <pc:sldMk cId="3526335932" sldId="266"/>
-            <ac:spMk id="3" creationId="{CCDEAB36-867D-95B6-8834-F42C5B9259D0}"/>
-          </ac:spMkLst>
-        </pc:spChg>
-        <pc:spChg chg="mod">
-          <ac:chgData name="Margo Bonal" userId="18c9fa0f-b53d-478b-9dc0-6ad88786c19f" providerId="ADAL" clId="{93D479E5-F67F-4B8A-A78F-A0B574A116B6}" dt="2026-03-21T14:09:45.490" v="517" actId="20577"/>
-          <ac:spMkLst>
-            <pc:docMk/>
-            <pc:sldMk cId="3526335932" sldId="266"/>
-            <ac:spMk id="4" creationId="{86ED9EE4-56A8-6AFD-BE9A-A35D2ABC59A0}"/>
           </ac:spMkLst>
         </pc:spChg>
       </pc:sldChg>
@@ -10284,6 +10286,424 @@
 <file path=ppt/slides/slide10.xml><?xml version="1.0" encoding="utf-8"?>
 <p:sld xmlns:a="http://schemas.openxmlformats.org/drawingml/2006/main" xmlns:r="http://schemas.openxmlformats.org/officeDocument/2006/relationships" xmlns:p="http://schemas.openxmlformats.org/presentationml/2006/main">
   <p:cSld>
+    <p:spTree>
+      <p:nvGrpSpPr>
+        <p:cNvPr id="1" name="">
+          <a:extLst>
+            <a:ext uri="{FF2B5EF4-FFF2-40B4-BE49-F238E27FC236}">
+              <a16:creationId xmlns:a16="http://schemas.microsoft.com/office/drawing/2014/main" id="{E81593F0-E5EC-5139-C3F4-2A8BDA9E1824}"/>
+            </a:ext>
+          </a:extLst>
+        </p:cNvPr>
+        <p:cNvGrpSpPr/>
+        <p:nvPr/>
+      </p:nvGrpSpPr>
+      <p:grpSpPr>
+        <a:xfrm>
+          <a:off x="0" y="0"/>
+          <a:ext cx="0" cy="0"/>
+          <a:chOff x="0" y="0"/>
+          <a:chExt cx="0" cy="0"/>
+        </a:xfrm>
+      </p:grpSpPr>
+      <p:pic>
+        <p:nvPicPr>
+          <p:cNvPr id="4" name="Picture 3">
+            <a:extLst>
+              <a:ext uri="{FF2B5EF4-FFF2-40B4-BE49-F238E27FC236}">
+                <a16:creationId xmlns:a16="http://schemas.microsoft.com/office/drawing/2014/main" id="{262795B3-1E27-E39A-27BD-1E0F28C2C129}"/>
+              </a:ext>
+            </a:extLst>
+          </p:cNvPr>
+          <p:cNvPicPr>
+            <a:picLocks noChangeAspect="1"/>
+          </p:cNvPicPr>
+          <p:nvPr/>
+        </p:nvPicPr>
+        <p:blipFill>
+          <a:blip r:embed="rId2"/>
+          <a:stretch>
+            <a:fillRect/>
+          </a:stretch>
+        </p:blipFill>
+        <p:spPr>
+          <a:xfrm>
+            <a:off x="414549" y="0"/>
+            <a:ext cx="11362901" cy="6858000"/>
+          </a:xfrm>
+          <a:prstGeom prst="rect">
+            <a:avLst/>
+          </a:prstGeom>
+        </p:spPr>
+      </p:pic>
+    </p:spTree>
+    <p:extLst>
+      <p:ext uri="{BB962C8B-B14F-4D97-AF65-F5344CB8AC3E}">
+        <p14:creationId xmlns:p14="http://schemas.microsoft.com/office/powerpoint/2010/main" val="655808794"/>
+      </p:ext>
+    </p:extLst>
+  </p:cSld>
+  <p:clrMapOvr>
+    <a:masterClrMapping/>
+  </p:clrMapOvr>
+</p:sld>
+</file>
+
+<file path=ppt/slides/slide11.xml><?xml version="1.0" encoding="utf-8"?>
+<p:sld xmlns:a="http://schemas.openxmlformats.org/drawingml/2006/main" xmlns:r="http://schemas.openxmlformats.org/officeDocument/2006/relationships" xmlns:p="http://schemas.openxmlformats.org/presentationml/2006/main">
+  <p:cSld>
+    <p:bg>
+      <p:bgPr>
+        <a:solidFill>
+          <a:schemeClr val="bg1"/>
+        </a:solidFill>
+        <a:effectLst/>
+      </p:bgPr>
+    </p:bg>
+    <p:spTree>
+      <p:nvGrpSpPr>
+        <p:cNvPr id="1" name="">
+          <a:extLst>
+            <a:ext uri="{FF2B5EF4-FFF2-40B4-BE49-F238E27FC236}">
+              <a16:creationId xmlns:a16="http://schemas.microsoft.com/office/drawing/2014/main" id="{38138CFD-A501-8AEC-C666-BED845111F6D}"/>
+            </a:ext>
+          </a:extLst>
+        </p:cNvPr>
+        <p:cNvGrpSpPr/>
+        <p:nvPr/>
+      </p:nvGrpSpPr>
+      <p:grpSpPr>
+        <a:xfrm>
+          <a:off x="0" y="0"/>
+          <a:ext cx="0" cy="0"/>
+          <a:chOff x="0" y="0"/>
+          <a:chExt cx="0" cy="0"/>
+        </a:xfrm>
+      </p:grpSpPr>
+      <p:sp useBgFill="1">
+        <p:nvSpPr>
+          <p:cNvPr id="21" name="Rectangle 20">
+            <a:extLst>
+              <a:ext uri="{FF2B5EF4-FFF2-40B4-BE49-F238E27FC236}">
+                <a16:creationId xmlns:a16="http://schemas.microsoft.com/office/drawing/2014/main" id="{356F68EF-088F-20DD-B4B1-6BCF0A8C9BF2}"/>
+              </a:ext>
+              <a:ext uri="{C183D7F6-B498-43B3-948B-1728B52AA6E4}">
+                <adec:decorative xmlns:adec="http://schemas.microsoft.com/office/drawing/2017/decorative" val="1"/>
+              </a:ext>
+            </a:extLst>
+          </p:cNvPr>
+          <p:cNvSpPr>
+            <a:spLocks noGrp="1" noRot="1" noChangeAspect="1" noMove="1" noResize="1" noEditPoints="1" noAdjustHandles="1" noChangeArrowheads="1" noChangeShapeType="1" noTextEdit="1"/>
+          </p:cNvSpPr>
+          <p:nvPr>
+            <p:extLst>
+              <p:ext uri="{386F3935-93C4-4BCD-93E2-E3B085C9AB24}">
+                <p16:designElem xmlns:p16="http://schemas.microsoft.com/office/powerpoint/2015/main" val="1"/>
+              </p:ext>
+            </p:extLst>
+          </p:nvPr>
+        </p:nvSpPr>
+        <p:spPr>
+          <a:xfrm>
+            <a:off x="0" y="0"/>
+            <a:ext cx="12191999" cy="6857365"/>
+          </a:xfrm>
+          <a:prstGeom prst="rect">
+            <a:avLst/>
+          </a:prstGeom>
+          <a:ln>
+            <a:noFill/>
+          </a:ln>
+        </p:spPr>
+        <p:style>
+          <a:lnRef idx="2">
+            <a:schemeClr val="accent1">
+              <a:shade val="50000"/>
+            </a:schemeClr>
+          </a:lnRef>
+          <a:fillRef idx="1">
+            <a:schemeClr val="accent1"/>
+          </a:fillRef>
+          <a:effectRef idx="0">
+            <a:schemeClr val="accent1"/>
+          </a:effectRef>
+          <a:fontRef idx="minor">
+            <a:schemeClr val="lt1"/>
+          </a:fontRef>
+        </p:style>
+        <p:txBody>
+          <a:bodyPr rtlCol="0" anchor="ctr"/>
+          <a:lstStyle/>
+          <a:p>
+            <a:pPr algn="ctr"/>
+            <a:endParaRPr lang="en-US"/>
+          </a:p>
+        </p:txBody>
+      </p:sp>
+      <p:sp>
+        <p:nvSpPr>
+          <p:cNvPr id="22" name="Rectangle 21">
+            <a:extLst>
+              <a:ext uri="{FF2B5EF4-FFF2-40B4-BE49-F238E27FC236}">
+                <a16:creationId xmlns:a16="http://schemas.microsoft.com/office/drawing/2014/main" id="{9EF082FE-D96F-0D2A-34AA-F987D0796D34}"/>
+              </a:ext>
+              <a:ext uri="{C183D7F6-B498-43B3-948B-1728B52AA6E4}">
+                <adec:decorative xmlns:adec="http://schemas.microsoft.com/office/drawing/2017/decorative" val="1"/>
+              </a:ext>
+            </a:extLst>
+          </p:cNvPr>
+          <p:cNvSpPr>
+            <a:spLocks noGrp="1" noRot="1" noChangeAspect="1" noMove="1" noResize="1" noEditPoints="1" noAdjustHandles="1" noChangeArrowheads="1" noChangeShapeType="1" noTextEdit="1"/>
+          </p:cNvSpPr>
+          <p:nvPr>
+            <p:extLst>
+              <p:ext uri="{386F3935-93C4-4BCD-93E2-E3B085C9AB24}">
+                <p16:designElem xmlns:p16="http://schemas.microsoft.com/office/powerpoint/2015/main" val="1"/>
+              </p:ext>
+            </p:extLst>
+          </p:nvPr>
+        </p:nvSpPr>
+        <p:spPr>
+          <a:xfrm>
+            <a:off x="0" y="1"/>
+            <a:ext cx="12192000" cy="5187142"/>
+          </a:xfrm>
+          <a:prstGeom prst="rect">
+            <a:avLst/>
+          </a:prstGeom>
+          <a:solidFill>
+            <a:schemeClr val="accent4"/>
+          </a:solidFill>
+          <a:ln>
+            <a:noFill/>
+          </a:ln>
+        </p:spPr>
+        <p:style>
+          <a:lnRef idx="2">
+            <a:schemeClr val="accent1">
+              <a:shade val="50000"/>
+            </a:schemeClr>
+          </a:lnRef>
+          <a:fillRef idx="1">
+            <a:schemeClr val="accent1"/>
+          </a:fillRef>
+          <a:effectRef idx="0">
+            <a:schemeClr val="accent1"/>
+          </a:effectRef>
+          <a:fontRef idx="minor">
+            <a:schemeClr val="lt1"/>
+          </a:fontRef>
+        </p:style>
+        <p:txBody>
+          <a:bodyPr rtlCol="0" anchor="ctr"/>
+          <a:lstStyle/>
+          <a:p>
+            <a:pPr algn="ctr"/>
+            <a:endParaRPr lang="en-US" dirty="0"/>
+          </a:p>
+        </p:txBody>
+      </p:sp>
+      <p:sp>
+        <p:nvSpPr>
+          <p:cNvPr id="23" name="Rectangle 22">
+            <a:extLst>
+              <a:ext uri="{FF2B5EF4-FFF2-40B4-BE49-F238E27FC236}">
+                <a16:creationId xmlns:a16="http://schemas.microsoft.com/office/drawing/2014/main" id="{0BE13FF0-F6F1-375E-D271-70DAE72E1AC7}"/>
+              </a:ext>
+              <a:ext uri="{C183D7F6-B498-43B3-948B-1728B52AA6E4}">
+                <adec:decorative xmlns:adec="http://schemas.microsoft.com/office/drawing/2017/decorative" val="1"/>
+              </a:ext>
+            </a:extLst>
+          </p:cNvPr>
+          <p:cNvSpPr>
+            <a:spLocks noGrp="1" noRot="1" noChangeAspect="1" noMove="1" noResize="1" noEditPoints="1" noAdjustHandles="1" noChangeArrowheads="1" noChangeShapeType="1" noTextEdit="1"/>
+          </p:cNvSpPr>
+          <p:nvPr>
+            <p:extLst>
+              <p:ext uri="{386F3935-93C4-4BCD-93E2-E3B085C9AB24}">
+                <p16:designElem xmlns:p16="http://schemas.microsoft.com/office/powerpoint/2015/main" val="1"/>
+              </p:ext>
+            </p:extLst>
+          </p:nvPr>
+        </p:nvSpPr>
+        <p:spPr>
+          <a:xfrm>
+            <a:off x="596464" y="551961"/>
+            <a:ext cx="10999072" cy="5399950"/>
+          </a:xfrm>
+          <a:prstGeom prst="rect">
+            <a:avLst/>
+          </a:prstGeom>
+          <a:solidFill>
+            <a:schemeClr val="bg1"/>
+          </a:solidFill>
+          <a:ln>
+            <a:noFill/>
+          </a:ln>
+          <a:effectLst>
+            <a:outerShdw blurRad="139700" dist="127000" dir="5400000" algn="t" rotWithShape="0">
+              <a:prstClr val="black">
+                <a:alpha val="15000"/>
+              </a:prstClr>
+            </a:outerShdw>
+          </a:effectLst>
+        </p:spPr>
+        <p:style>
+          <a:lnRef idx="2">
+            <a:schemeClr val="accent1">
+              <a:shade val="50000"/>
+            </a:schemeClr>
+          </a:lnRef>
+          <a:fillRef idx="1">
+            <a:schemeClr val="accent1"/>
+          </a:fillRef>
+          <a:effectRef idx="0">
+            <a:schemeClr val="accent1"/>
+          </a:effectRef>
+          <a:fontRef idx="minor">
+            <a:schemeClr val="lt1"/>
+          </a:fontRef>
+        </p:style>
+        <p:txBody>
+          <a:bodyPr rtlCol="0" anchor="ctr"/>
+          <a:lstStyle/>
+          <a:p>
+            <a:pPr algn="ctr"/>
+            <a:endParaRPr lang="en-US"/>
+          </a:p>
+        </p:txBody>
+      </p:sp>
+      <p:cxnSp>
+        <p:nvCxnSpPr>
+          <p:cNvPr id="25" name="Straight Connector 24">
+            <a:extLst>
+              <a:ext uri="{FF2B5EF4-FFF2-40B4-BE49-F238E27FC236}">
+                <a16:creationId xmlns:a16="http://schemas.microsoft.com/office/drawing/2014/main" id="{3A7F67B2-22A5-7F2D-13EB-E06229F5CB46}"/>
+              </a:ext>
+              <a:ext uri="{C183D7F6-B498-43B3-948B-1728B52AA6E4}">
+                <adec:decorative xmlns:adec="http://schemas.microsoft.com/office/drawing/2017/decorative" val="1"/>
+              </a:ext>
+            </a:extLst>
+          </p:cNvPr>
+          <p:cNvCxnSpPr>
+            <a:cxnSpLocks noGrp="1" noRot="1" noChangeAspect="1" noMove="1" noResize="1" noEditPoints="1" noAdjustHandles="1" noChangeArrowheads="1" noChangeShapeType="1"/>
+          </p:cNvCxnSpPr>
+          <p:nvPr>
+            <p:extLst>
+              <p:ext uri="{386F3935-93C4-4BCD-93E2-E3B085C9AB24}">
+                <p16:designElem xmlns:p16="http://schemas.microsoft.com/office/powerpoint/2015/main" val="1"/>
+              </p:ext>
+            </p:extLst>
+          </p:nvPr>
+        </p:nvCxnSpPr>
+        <p:spPr>
+          <a:xfrm flipH="1">
+            <a:off x="596464" y="6329769"/>
+            <a:ext cx="11000232" cy="0"/>
+          </a:xfrm>
+          <a:prstGeom prst="line">
+            <a:avLst/>
+          </a:prstGeom>
+          <a:ln w="152400">
+            <a:solidFill>
+              <a:schemeClr val="accent4"/>
+            </a:solidFill>
+          </a:ln>
+        </p:spPr>
+        <p:style>
+          <a:lnRef idx="1">
+            <a:schemeClr val="accent1"/>
+          </a:lnRef>
+          <a:fillRef idx="0">
+            <a:schemeClr val="accent1"/>
+          </a:fillRef>
+          <a:effectRef idx="0">
+            <a:schemeClr val="accent1"/>
+          </a:effectRef>
+          <a:fontRef idx="minor">
+            <a:schemeClr val="tx1"/>
+          </a:fontRef>
+        </p:style>
+      </p:cxnSp>
+      <p:sp>
+        <p:nvSpPr>
+          <p:cNvPr id="9" name="Title 1">
+            <a:extLst>
+              <a:ext uri="{FF2B5EF4-FFF2-40B4-BE49-F238E27FC236}">
+                <a16:creationId xmlns:a16="http://schemas.microsoft.com/office/drawing/2014/main" id="{D6D36DC8-D9BF-8C26-69EA-ED89E34DB644}"/>
+              </a:ext>
+            </a:extLst>
+          </p:cNvPr>
+          <p:cNvSpPr>
+            <a:spLocks noGrp="1"/>
+          </p:cNvSpPr>
+          <p:nvPr>
+            <p:ph type="title"/>
+          </p:nvPr>
+        </p:nvSpPr>
+        <p:spPr>
+          <a:xfrm>
+            <a:off x="4008559" y="768350"/>
+            <a:ext cx="4162181" cy="920920"/>
+          </a:xfrm>
+        </p:spPr>
+        <p:txBody>
+          <a:bodyPr>
+            <a:normAutofit fontScale="90000"/>
+          </a:bodyPr>
+          <a:lstStyle/>
+          <a:p>
+            <a:r>
+              <a:rPr lang="en-US" dirty="0"/>
+              <a:t>Week 12 Plan</a:t>
+            </a:r>
+          </a:p>
+        </p:txBody>
+      </p:sp>
+      <p:graphicFrame>
+        <p:nvGraphicFramePr>
+          <p:cNvPr id="27" name="Text Placeholder 2">
+            <a:extLst>
+              <a:ext uri="{FF2B5EF4-FFF2-40B4-BE49-F238E27FC236}">
+                <a16:creationId xmlns:a16="http://schemas.microsoft.com/office/drawing/2014/main" id="{D6B93F0B-FEB0-EDAB-CFE1-A57DEFE97FCD}"/>
+              </a:ext>
+            </a:extLst>
+          </p:cNvPr>
+          <p:cNvGraphicFramePr/>
+          <p:nvPr>
+            <p:extLst>
+              <p:ext uri="{D42A27DB-BD31-4B8C-83A1-F6EECF244321}">
+                <p14:modId xmlns:p14="http://schemas.microsoft.com/office/powerpoint/2010/main" val="3016178620"/>
+              </p:ext>
+            </p:extLst>
+          </p:nvPr>
+        </p:nvGraphicFramePr>
+        <p:xfrm>
+          <a:off x="838199" y="2688113"/>
+          <a:ext cx="10515600" cy="3050990"/>
+        </p:xfrm>
+        <a:graphic>
+          <a:graphicData uri="http://schemas.openxmlformats.org/drawingml/2006/diagram">
+            <dgm:relIds xmlns:dgm="http://schemas.openxmlformats.org/drawingml/2006/diagram" xmlns:r="http://schemas.openxmlformats.org/officeDocument/2006/relationships" r:dm="rId2" r:lo="rId3" r:qs="rId4" r:cs="rId5"/>
+          </a:graphicData>
+        </a:graphic>
+      </p:graphicFrame>
+    </p:spTree>
+    <p:extLst>
+      <p:ext uri="{BB962C8B-B14F-4D97-AF65-F5344CB8AC3E}">
+        <p14:creationId xmlns:p14="http://schemas.microsoft.com/office/powerpoint/2010/main" val="2561402868"/>
+      </p:ext>
+    </p:extLst>
+  </p:cSld>
+  <p:clrMapOvr>
+    <a:masterClrMapping/>
+  </p:clrMapOvr>
+</p:sld>
+</file>
+
+<file path=ppt/slides/slide12.xml><?xml version="1.0" encoding="utf-8"?>
+<p:sld xmlns:a="http://schemas.openxmlformats.org/drawingml/2006/main" xmlns:r="http://schemas.openxmlformats.org/officeDocument/2006/relationships" xmlns:p="http://schemas.openxmlformats.org/presentationml/2006/main">
+  <p:cSld>
     <p:bg>
       <p:bgPr>
         <a:solidFill>
@@ -10669,7 +11089,7 @@
 </p:sld>
 </file>
 
-<file path=ppt/slides/slide11.xml><?xml version="1.0" encoding="utf-8"?>
+<file path=ppt/slides/slide13.xml><?xml version="1.0" encoding="utf-8"?>
 <p:sld xmlns:a="http://schemas.openxmlformats.org/drawingml/2006/main" xmlns:r="http://schemas.openxmlformats.org/officeDocument/2006/relationships" xmlns:p="http://schemas.openxmlformats.org/presentationml/2006/main">
   <p:cSld>
     <p:bg>
@@ -12043,6 +12463,16 @@
               <a:buFont typeface="Arial" panose="020B0604020202020204" pitchFamily="34" charset="0"/>
               <a:buChar char="•"/>
             </a:pPr>
+            <a:r>
+              <a:rPr lang="en-US" dirty="0"/>
+              <a:t>Challenges Page Progress</a:t>
+            </a:r>
+          </a:p>
+          <a:p>
+            <a:pPr marL="342900" indent="-342900">
+              <a:buFont typeface="Arial" panose="020B0604020202020204" pitchFamily="34" charset="0"/>
+              <a:buChar char="•"/>
+            </a:pPr>
             <a:endParaRPr lang="en-US" dirty="0"/>
           </a:p>
           <a:p>
@@ -12378,6 +12808,20 @@
                 </a:solidFill>
               </a:rPr>
               <a:t>Could not populate database tables with athlete emails, they were not publicly available. Also, the amount of athletes would have been a lot of inserts into the database table</a:t>
+            </a:r>
+          </a:p>
+          <a:p>
+            <a:pPr marL="342900" indent="-342900">
+              <a:buFont typeface="+mj-lt"/>
+              <a:buAutoNum type="arabicPeriod"/>
+            </a:pPr>
+            <a:r>
+              <a:rPr lang="en-US" sz="2000" dirty="0">
+                <a:solidFill>
+                  <a:schemeClr val="tx1"/>
+                </a:solidFill>
+              </a:rPr>
+              <a:t>Adding pictures to challenges</a:t>
             </a:r>
           </a:p>
         </p:txBody>
@@ -13369,6 +13813,20 @@
               <a:t>Populated the database tables with coach emails instead, as this information was publicly available and it becomes more efficient to let the coach into the page and invite their athletes as opposed to having every single athlete in the table on startup</a:t>
             </a:r>
           </a:p>
+          <a:p>
+            <a:pPr marL="342900" indent="-342900">
+              <a:buFont typeface="+mj-lt"/>
+              <a:buAutoNum type="arabicPeriod"/>
+            </a:pPr>
+            <a:r>
+              <a:rPr lang="en-US" sz="2000" dirty="0">
+                <a:solidFill>
+                  <a:schemeClr val="tx1"/>
+                </a:solidFill>
+              </a:rPr>
+              <a:t>Decided not to use pictures for individual challenges as it will fill the database quickly</a:t>
+            </a:r>
+          </a:p>
         </p:txBody>
       </p:sp>
     </p:spTree>
@@ -14106,20 +14564,12 @@
 <file path=ppt/slides/slide9.xml><?xml version="1.0" encoding="utf-8"?>
 <p:sld xmlns:a="http://schemas.openxmlformats.org/drawingml/2006/main" xmlns:r="http://schemas.openxmlformats.org/officeDocument/2006/relationships" xmlns:p="http://schemas.openxmlformats.org/presentationml/2006/main">
   <p:cSld>
-    <p:bg>
-      <p:bgPr>
-        <a:solidFill>
-          <a:schemeClr val="bg1"/>
-        </a:solidFill>
-        <a:effectLst/>
-      </p:bgPr>
-    </p:bg>
     <p:spTree>
       <p:nvGrpSpPr>
         <p:cNvPr id="1" name="">
           <a:extLst>
             <a:ext uri="{FF2B5EF4-FFF2-40B4-BE49-F238E27FC236}">
-              <a16:creationId xmlns:a16="http://schemas.microsoft.com/office/drawing/2014/main" id="{38138CFD-A501-8AEC-C666-BED845111F6D}"/>
+              <a16:creationId xmlns:a16="http://schemas.microsoft.com/office/drawing/2014/main" id="{A006203E-28F1-BA0D-25E9-3D8E5EFB61D4}"/>
             </a:ext>
           </a:extLst>
         </p:cNvPr>
@@ -14134,318 +14584,40 @@
           <a:chExt cx="0" cy="0"/>
         </a:xfrm>
       </p:grpSpPr>
-      <p:sp useBgFill="1">
-        <p:nvSpPr>
-          <p:cNvPr id="21" name="Rectangle 20">
+      <p:pic>
+        <p:nvPicPr>
+          <p:cNvPr id="3" name="Picture 2">
             <a:extLst>
               <a:ext uri="{FF2B5EF4-FFF2-40B4-BE49-F238E27FC236}">
-                <a16:creationId xmlns:a16="http://schemas.microsoft.com/office/drawing/2014/main" id="{356F68EF-088F-20DD-B4B1-6BCF0A8C9BF2}"/>
-              </a:ext>
-              <a:ext uri="{C183D7F6-B498-43B3-948B-1728B52AA6E4}">
-                <adec:decorative xmlns:adec="http://schemas.microsoft.com/office/drawing/2017/decorative" val="1"/>
+                <a16:creationId xmlns:a16="http://schemas.microsoft.com/office/drawing/2014/main" id="{5E1D5C93-D949-B81A-BB7C-0C29484C1FF8}"/>
               </a:ext>
             </a:extLst>
           </p:cNvPr>
-          <p:cNvSpPr>
-            <a:spLocks noGrp="1" noRot="1" noChangeAspect="1" noMove="1" noResize="1" noEditPoints="1" noAdjustHandles="1" noChangeArrowheads="1" noChangeShapeType="1" noTextEdit="1"/>
-          </p:cNvSpPr>
-          <p:nvPr>
-            <p:extLst>
-              <p:ext uri="{386F3935-93C4-4BCD-93E2-E3B085C9AB24}">
-                <p16:designElem xmlns:p16="http://schemas.microsoft.com/office/powerpoint/2015/main" val="1"/>
-              </p:ext>
-            </p:extLst>
-          </p:nvPr>
-        </p:nvSpPr>
+          <p:cNvPicPr>
+            <a:picLocks noChangeAspect="1"/>
+          </p:cNvPicPr>
+          <p:nvPr/>
+        </p:nvPicPr>
+        <p:blipFill>
+          <a:blip r:embed="rId2"/>
+          <a:stretch>
+            <a:fillRect/>
+          </a:stretch>
+        </p:blipFill>
         <p:spPr>
           <a:xfrm>
-            <a:off x="0" y="0"/>
-            <a:ext cx="12191999" cy="6857365"/>
+            <a:off x="0" y="19810"/>
+            <a:ext cx="12192000" cy="6818380"/>
           </a:xfrm>
           <a:prstGeom prst="rect">
             <a:avLst/>
           </a:prstGeom>
-          <a:ln>
-            <a:noFill/>
-          </a:ln>
         </p:spPr>
-        <p:style>
-          <a:lnRef idx="2">
-            <a:schemeClr val="accent1">
-              <a:shade val="50000"/>
-            </a:schemeClr>
-          </a:lnRef>
-          <a:fillRef idx="1">
-            <a:schemeClr val="accent1"/>
-          </a:fillRef>
-          <a:effectRef idx="0">
-            <a:schemeClr val="accent1"/>
-          </a:effectRef>
-          <a:fontRef idx="minor">
-            <a:schemeClr val="lt1"/>
-          </a:fontRef>
-        </p:style>
-        <p:txBody>
-          <a:bodyPr rtlCol="0" anchor="ctr"/>
-          <a:lstStyle/>
-          <a:p>
-            <a:pPr algn="ctr"/>
-            <a:endParaRPr lang="en-US"/>
-          </a:p>
-        </p:txBody>
-      </p:sp>
-      <p:sp>
-        <p:nvSpPr>
-          <p:cNvPr id="22" name="Rectangle 21">
-            <a:extLst>
-              <a:ext uri="{FF2B5EF4-FFF2-40B4-BE49-F238E27FC236}">
-                <a16:creationId xmlns:a16="http://schemas.microsoft.com/office/drawing/2014/main" id="{9EF082FE-D96F-0D2A-34AA-F987D0796D34}"/>
-              </a:ext>
-              <a:ext uri="{C183D7F6-B498-43B3-948B-1728B52AA6E4}">
-                <adec:decorative xmlns:adec="http://schemas.microsoft.com/office/drawing/2017/decorative" val="1"/>
-              </a:ext>
-            </a:extLst>
-          </p:cNvPr>
-          <p:cNvSpPr>
-            <a:spLocks noGrp="1" noRot="1" noChangeAspect="1" noMove="1" noResize="1" noEditPoints="1" noAdjustHandles="1" noChangeArrowheads="1" noChangeShapeType="1" noTextEdit="1"/>
-          </p:cNvSpPr>
-          <p:nvPr>
-            <p:extLst>
-              <p:ext uri="{386F3935-93C4-4BCD-93E2-E3B085C9AB24}">
-                <p16:designElem xmlns:p16="http://schemas.microsoft.com/office/powerpoint/2015/main" val="1"/>
-              </p:ext>
-            </p:extLst>
-          </p:nvPr>
-        </p:nvSpPr>
-        <p:spPr>
-          <a:xfrm>
-            <a:off x="0" y="1"/>
-            <a:ext cx="12192000" cy="5187142"/>
-          </a:xfrm>
-          <a:prstGeom prst="rect">
-            <a:avLst/>
-          </a:prstGeom>
-          <a:solidFill>
-            <a:schemeClr val="accent4"/>
-          </a:solidFill>
-          <a:ln>
-            <a:noFill/>
-          </a:ln>
-        </p:spPr>
-        <p:style>
-          <a:lnRef idx="2">
-            <a:schemeClr val="accent1">
-              <a:shade val="50000"/>
-            </a:schemeClr>
-          </a:lnRef>
-          <a:fillRef idx="1">
-            <a:schemeClr val="accent1"/>
-          </a:fillRef>
-          <a:effectRef idx="0">
-            <a:schemeClr val="accent1"/>
-          </a:effectRef>
-          <a:fontRef idx="minor">
-            <a:schemeClr val="lt1"/>
-          </a:fontRef>
-        </p:style>
-        <p:txBody>
-          <a:bodyPr rtlCol="0" anchor="ctr"/>
-          <a:lstStyle/>
-          <a:p>
-            <a:pPr algn="ctr"/>
-            <a:endParaRPr lang="en-US" dirty="0"/>
-          </a:p>
-        </p:txBody>
-      </p:sp>
-      <p:sp>
-        <p:nvSpPr>
-          <p:cNvPr id="23" name="Rectangle 22">
-            <a:extLst>
-              <a:ext uri="{FF2B5EF4-FFF2-40B4-BE49-F238E27FC236}">
-                <a16:creationId xmlns:a16="http://schemas.microsoft.com/office/drawing/2014/main" id="{0BE13FF0-F6F1-375E-D271-70DAE72E1AC7}"/>
-              </a:ext>
-              <a:ext uri="{C183D7F6-B498-43B3-948B-1728B52AA6E4}">
-                <adec:decorative xmlns:adec="http://schemas.microsoft.com/office/drawing/2017/decorative" val="1"/>
-              </a:ext>
-            </a:extLst>
-          </p:cNvPr>
-          <p:cNvSpPr>
-            <a:spLocks noGrp="1" noRot="1" noChangeAspect="1" noMove="1" noResize="1" noEditPoints="1" noAdjustHandles="1" noChangeArrowheads="1" noChangeShapeType="1" noTextEdit="1"/>
-          </p:cNvSpPr>
-          <p:nvPr>
-            <p:extLst>
-              <p:ext uri="{386F3935-93C4-4BCD-93E2-E3B085C9AB24}">
-                <p16:designElem xmlns:p16="http://schemas.microsoft.com/office/powerpoint/2015/main" val="1"/>
-              </p:ext>
-            </p:extLst>
-          </p:nvPr>
-        </p:nvSpPr>
-        <p:spPr>
-          <a:xfrm>
-            <a:off x="596464" y="551961"/>
-            <a:ext cx="10999072" cy="5399950"/>
-          </a:xfrm>
-          <a:prstGeom prst="rect">
-            <a:avLst/>
-          </a:prstGeom>
-          <a:solidFill>
-            <a:schemeClr val="bg1"/>
-          </a:solidFill>
-          <a:ln>
-            <a:noFill/>
-          </a:ln>
-          <a:effectLst>
-            <a:outerShdw blurRad="139700" dist="127000" dir="5400000" algn="t" rotWithShape="0">
-              <a:prstClr val="black">
-                <a:alpha val="15000"/>
-              </a:prstClr>
-            </a:outerShdw>
-          </a:effectLst>
-        </p:spPr>
-        <p:style>
-          <a:lnRef idx="2">
-            <a:schemeClr val="accent1">
-              <a:shade val="50000"/>
-            </a:schemeClr>
-          </a:lnRef>
-          <a:fillRef idx="1">
-            <a:schemeClr val="accent1"/>
-          </a:fillRef>
-          <a:effectRef idx="0">
-            <a:schemeClr val="accent1"/>
-          </a:effectRef>
-          <a:fontRef idx="minor">
-            <a:schemeClr val="lt1"/>
-          </a:fontRef>
-        </p:style>
-        <p:txBody>
-          <a:bodyPr rtlCol="0" anchor="ctr"/>
-          <a:lstStyle/>
-          <a:p>
-            <a:pPr algn="ctr"/>
-            <a:endParaRPr lang="en-US"/>
-          </a:p>
-        </p:txBody>
-      </p:sp>
-      <p:cxnSp>
-        <p:nvCxnSpPr>
-          <p:cNvPr id="25" name="Straight Connector 24">
-            <a:extLst>
-              <a:ext uri="{FF2B5EF4-FFF2-40B4-BE49-F238E27FC236}">
-                <a16:creationId xmlns:a16="http://schemas.microsoft.com/office/drawing/2014/main" id="{3A7F67B2-22A5-7F2D-13EB-E06229F5CB46}"/>
-              </a:ext>
-              <a:ext uri="{C183D7F6-B498-43B3-948B-1728B52AA6E4}">
-                <adec:decorative xmlns:adec="http://schemas.microsoft.com/office/drawing/2017/decorative" val="1"/>
-              </a:ext>
-            </a:extLst>
-          </p:cNvPr>
-          <p:cNvCxnSpPr>
-            <a:cxnSpLocks noGrp="1" noRot="1" noChangeAspect="1" noMove="1" noResize="1" noEditPoints="1" noAdjustHandles="1" noChangeArrowheads="1" noChangeShapeType="1"/>
-          </p:cNvCxnSpPr>
-          <p:nvPr>
-            <p:extLst>
-              <p:ext uri="{386F3935-93C4-4BCD-93E2-E3B085C9AB24}">
-                <p16:designElem xmlns:p16="http://schemas.microsoft.com/office/powerpoint/2015/main" val="1"/>
-              </p:ext>
-            </p:extLst>
-          </p:nvPr>
-        </p:nvCxnSpPr>
-        <p:spPr>
-          <a:xfrm flipH="1">
-            <a:off x="596464" y="6329769"/>
-            <a:ext cx="11000232" cy="0"/>
-          </a:xfrm>
-          <a:prstGeom prst="line">
-            <a:avLst/>
-          </a:prstGeom>
-          <a:ln w="152400">
-            <a:solidFill>
-              <a:schemeClr val="accent4"/>
-            </a:solidFill>
-          </a:ln>
-        </p:spPr>
-        <p:style>
-          <a:lnRef idx="1">
-            <a:schemeClr val="accent1"/>
-          </a:lnRef>
-          <a:fillRef idx="0">
-            <a:schemeClr val="accent1"/>
-          </a:fillRef>
-          <a:effectRef idx="0">
-            <a:schemeClr val="accent1"/>
-          </a:effectRef>
-          <a:fontRef idx="minor">
-            <a:schemeClr val="tx1"/>
-          </a:fontRef>
-        </p:style>
-      </p:cxnSp>
-      <p:sp>
-        <p:nvSpPr>
-          <p:cNvPr id="9" name="Title 1">
-            <a:extLst>
-              <a:ext uri="{FF2B5EF4-FFF2-40B4-BE49-F238E27FC236}">
-                <a16:creationId xmlns:a16="http://schemas.microsoft.com/office/drawing/2014/main" id="{D6D36DC8-D9BF-8C26-69EA-ED89E34DB644}"/>
-              </a:ext>
-            </a:extLst>
-          </p:cNvPr>
-          <p:cNvSpPr>
-            <a:spLocks noGrp="1"/>
-          </p:cNvSpPr>
-          <p:nvPr>
-            <p:ph type="title"/>
-          </p:nvPr>
-        </p:nvSpPr>
-        <p:spPr>
-          <a:xfrm>
-            <a:off x="4008559" y="768350"/>
-            <a:ext cx="4162181" cy="920920"/>
-          </a:xfrm>
-        </p:spPr>
-        <p:txBody>
-          <a:bodyPr>
-            <a:normAutofit fontScale="90000"/>
-          </a:bodyPr>
-          <a:lstStyle/>
-          <a:p>
-            <a:r>
-              <a:rPr lang="en-US" dirty="0"/>
-              <a:t>Week 12 Plan</a:t>
-            </a:r>
-          </a:p>
-        </p:txBody>
-      </p:sp>
-      <p:graphicFrame>
-        <p:nvGraphicFramePr>
-          <p:cNvPr id="27" name="Text Placeholder 2">
-            <a:extLst>
-              <a:ext uri="{FF2B5EF4-FFF2-40B4-BE49-F238E27FC236}">
-                <a16:creationId xmlns:a16="http://schemas.microsoft.com/office/drawing/2014/main" id="{D6B93F0B-FEB0-EDAB-CFE1-A57DEFE97FCD}"/>
-              </a:ext>
-            </a:extLst>
-          </p:cNvPr>
-          <p:cNvGraphicFramePr/>
-          <p:nvPr>
-            <p:extLst>
-              <p:ext uri="{D42A27DB-BD31-4B8C-83A1-F6EECF244321}">
-                <p14:modId xmlns:p14="http://schemas.microsoft.com/office/powerpoint/2010/main" val="3016178620"/>
-              </p:ext>
-            </p:extLst>
-          </p:nvPr>
-        </p:nvGraphicFramePr>
-        <p:xfrm>
-          <a:off x="838199" y="2688113"/>
-          <a:ext cx="10515600" cy="3050990"/>
-        </p:xfrm>
-        <a:graphic>
-          <a:graphicData uri="http://schemas.openxmlformats.org/drawingml/2006/diagram">
-            <dgm:relIds xmlns:dgm="http://schemas.openxmlformats.org/drawingml/2006/diagram" xmlns:r="http://schemas.openxmlformats.org/officeDocument/2006/relationships" r:dm="rId2" r:lo="rId3" r:qs="rId4" r:cs="rId5"/>
-          </a:graphicData>
-        </a:graphic>
-      </p:graphicFrame>
+      </p:pic>
     </p:spTree>
     <p:extLst>
       <p:ext uri="{BB962C8B-B14F-4D97-AF65-F5344CB8AC3E}">
-        <p14:creationId xmlns:p14="http://schemas.microsoft.com/office/powerpoint/2010/main" val="2561402868"/>
+        <p14:creationId xmlns:p14="http://schemas.microsoft.com/office/powerpoint/2010/main" val="4185853212"/>
       </p:ext>
     </p:extLst>
   </p:cSld>

</xml_diff>

<commit_message>
fixed report and slides from being overwritten
</commit_message>
<xml_diff>
--- a/Documentation/Weekly Report/week11/CMSC-4920-Week11-Group2.pptx
+++ b/Documentation/Weekly Report/week11/CMSC-4920-Week11-Group2.pptx
@@ -5,7 +5,7 @@
     <p:sldMasterId id="2147483648" r:id="rId1"/>
   </p:sldMasterIdLst>
   <p:notesMasterIdLst>
-    <p:notesMasterId r:id="rId15"/>
+    <p:notesMasterId r:id="rId16"/>
   </p:notesMasterIdLst>
   <p:sldIdLst>
     <p:sldId id="256" r:id="rId2"/>
@@ -18,9 +18,10 @@
     <p:sldId id="267" r:id="rId9"/>
     <p:sldId id="270" r:id="rId10"/>
     <p:sldId id="271" r:id="rId11"/>
-    <p:sldId id="264" r:id="rId12"/>
-    <p:sldId id="259" r:id="rId13"/>
-    <p:sldId id="260" r:id="rId14"/>
+    <p:sldId id="272" r:id="rId12"/>
+    <p:sldId id="264" r:id="rId13"/>
+    <p:sldId id="259" r:id="rId14"/>
+    <p:sldId id="260" r:id="rId15"/>
   </p:sldIdLst>
   <p:sldSz cx="12192000" cy="6858000"/>
   <p:notesSz cx="6858000" cy="9144000"/>
@@ -131,75 +132,13 @@
 <p1510:revInfo xmlns:a="http://schemas.openxmlformats.org/drawingml/2006/main" xmlns:r="http://schemas.openxmlformats.org/officeDocument/2006/relationships" xmlns:p1510="http://schemas.microsoft.com/office/powerpoint/2015/10/main">
   <p1510:revLst>
     <p1510:client id="{06411FC2-7443-4BF5-B8F4-5EEEE928CA1B}" v="1" dt="2026-03-29T13:00:01.797"/>
-    <p1510:client id="{E4911506-1446-4B59-A2E1-F4B0482CAD7F}" v="4" dt="2026-03-28T15:09:02.563"/>
+    <p1510:client id="{77306D07-9C8A-416F-9B20-89AAB5815DA9}" v="2" dt="2026-03-30T01:09:55.841"/>
   </p1510:revLst>
 </p1510:revInfo>
 </file>
 
 <file path=ppt/changesInfos/changesInfo1.xml><?xml version="1.0" encoding="utf-8"?>
 <pc:chgInfo xmlns:a="http://schemas.openxmlformats.org/drawingml/2006/main" xmlns:r="http://schemas.openxmlformats.org/officeDocument/2006/relationships" xmlns:ac="http://schemas.microsoft.com/office/drawing/2013/main/command" xmlns:pc="http://schemas.microsoft.com/office/powerpoint/2013/main/command">
-  <pc:docChgLst>
-    <pc:chgData name="Margo Bonal" userId="18c9fa0f-b53d-478b-9dc0-6ad88786c19f" providerId="ADAL" clId="{93D479E5-F67F-4B8A-A78F-A0B574A116B6}"/>
-    <pc:docChg chg="undo custSel addSld delSld modSld">
-      <pc:chgData name="Margo Bonal" userId="18c9fa0f-b53d-478b-9dc0-6ad88786c19f" providerId="ADAL" clId="{93D479E5-F67F-4B8A-A78F-A0B574A116B6}" dt="2026-03-21T14:21:56.751" v="935" actId="27636"/>
-      <pc:docMkLst>
-        <pc:docMk/>
-      </pc:docMkLst>
-      <pc:sldChg chg="modSp mod">
-        <pc:chgData name="Margo Bonal" userId="18c9fa0f-b53d-478b-9dc0-6ad88786c19f" providerId="ADAL" clId="{93D479E5-F67F-4B8A-A78F-A0B574A116B6}" dt="2026-03-21T14:21:56.751" v="935" actId="27636"/>
-        <pc:sldMkLst>
-          <pc:docMk/>
-          <pc:sldMk cId="2561402868" sldId="264"/>
-        </pc:sldMkLst>
-        <pc:spChg chg="mod">
-          <ac:chgData name="Margo Bonal" userId="18c9fa0f-b53d-478b-9dc0-6ad88786c19f" providerId="ADAL" clId="{93D479E5-F67F-4B8A-A78F-A0B574A116B6}" dt="2026-03-21T14:21:56.751" v="935" actId="27636"/>
-          <ac:spMkLst>
-            <pc:docMk/>
-            <pc:sldMk cId="2561402868" sldId="264"/>
-            <ac:spMk id="9" creationId="{D6D36DC8-D9BF-8C26-69EA-ED89E34DB644}"/>
-          </ac:spMkLst>
-        </pc:spChg>
-        <pc:graphicFrameChg chg="mod modGraphic">
-          <ac:chgData name="Margo Bonal" userId="18c9fa0f-b53d-478b-9dc0-6ad88786c19f" providerId="ADAL" clId="{93D479E5-F67F-4B8A-A78F-A0B574A116B6}" dt="2026-03-21T14:21:54.477" v="931" actId="20577"/>
-          <ac:graphicFrameMkLst>
-            <pc:docMk/>
-            <pc:sldMk cId="2561402868" sldId="264"/>
-            <ac:graphicFrameMk id="27" creationId="{D6B93F0B-FEB0-EDAB-CFE1-A57DEFE97FCD}"/>
-          </ac:graphicFrameMkLst>
-        </pc:graphicFrameChg>
-      </pc:sldChg>
-      <pc:sldChg chg="delSp modSp mod">
-        <pc:chgData name="Margo Bonal" userId="18c9fa0f-b53d-478b-9dc0-6ad88786c19f" providerId="ADAL" clId="{93D479E5-F67F-4B8A-A78F-A0B574A116B6}" dt="2026-03-21T14:09:41.161" v="486"/>
-        <pc:sldMkLst>
-          <pc:docMk/>
-          <pc:sldMk cId="2428741132" sldId="265"/>
-        </pc:sldMkLst>
-      </pc:sldChg>
-      <pc:sldChg chg="modSp mod">
-        <pc:chgData name="Margo Bonal" userId="18c9fa0f-b53d-478b-9dc0-6ad88786c19f" providerId="ADAL" clId="{93D479E5-F67F-4B8A-A78F-A0B574A116B6}" dt="2026-03-21T14:09:48.188" v="518" actId="20577"/>
-        <pc:sldMkLst>
-          <pc:docMk/>
-          <pc:sldMk cId="3526335932" sldId="266"/>
-        </pc:sldMkLst>
-        <pc:spChg chg="mod">
-          <ac:chgData name="Margo Bonal" userId="18c9fa0f-b53d-478b-9dc0-6ad88786c19f" providerId="ADAL" clId="{93D479E5-F67F-4B8A-A78F-A0B574A116B6}" dt="2026-03-21T14:09:48.188" v="518" actId="20577"/>
-          <ac:spMkLst>
-            <pc:docMk/>
-            <pc:sldMk cId="3526335932" sldId="266"/>
-            <ac:spMk id="3" creationId="{CCDEAB36-867D-95B6-8834-F42C5B9259D0}"/>
-          </ac:spMkLst>
-        </pc:spChg>
-        <pc:spChg chg="mod">
-          <ac:chgData name="Margo Bonal" userId="18c9fa0f-b53d-478b-9dc0-6ad88786c19f" providerId="ADAL" clId="{93D479E5-F67F-4B8A-A78F-A0B574A116B6}" dt="2026-03-21T14:09:45.490" v="517" actId="20577"/>
-          <ac:spMkLst>
-            <pc:docMk/>
-            <pc:sldMk cId="3526335932" sldId="266"/>
-            <ac:spMk id="4" creationId="{86ED9EE4-56A8-6AFD-BE9A-A35D2ABC59A0}"/>
-          </ac:spMkLst>
-        </pc:spChg>
-      </pc:sldChg>
-    </pc:docChg>
-  </pc:docChgLst>
   <pc:docChgLst>
     <pc:chgData name="John Gerega" userId="bd3e1e46fb6a714b" providerId="LiveId" clId="{45F0C402-C550-4C82-B31D-5B32217A5E94}"/>
     <pc:docChg chg="undo custSel addSld delSld modSld">
@@ -287,6 +226,147 @@
     </pc:docChg>
   </pc:docChgLst>
   <pc:docChgLst>
+    <pc:chgData name="Margo Bonal" userId="18c9fa0f-b53d-478b-9dc0-6ad88786c19f" providerId="ADAL" clId="{93D479E5-F67F-4B8A-A78F-A0B574A116B6}"/>
+    <pc:docChg chg="undo custSel addSld delSld modSld">
+      <pc:chgData name="Margo Bonal" userId="18c9fa0f-b53d-478b-9dc0-6ad88786c19f" providerId="ADAL" clId="{93D479E5-F67F-4B8A-A78F-A0B574A116B6}" dt="2026-03-30T01:10:14.587" v="969" actId="14100"/>
+      <pc:docMkLst>
+        <pc:docMk/>
+      </pc:docMkLst>
+      <pc:sldChg chg="modSp mod">
+        <pc:chgData name="Margo Bonal" userId="18c9fa0f-b53d-478b-9dc0-6ad88786c19f" providerId="ADAL" clId="{93D479E5-F67F-4B8A-A78F-A0B574A116B6}" dt="2026-03-21T14:21:56.751" v="935" actId="27636"/>
+        <pc:sldMkLst>
+          <pc:docMk/>
+          <pc:sldMk cId="2561402868" sldId="264"/>
+        </pc:sldMkLst>
+        <pc:spChg chg="mod">
+          <ac:chgData name="Margo Bonal" userId="18c9fa0f-b53d-478b-9dc0-6ad88786c19f" providerId="ADAL" clId="{93D479E5-F67F-4B8A-A78F-A0B574A116B6}" dt="2026-03-21T14:21:56.751" v="935" actId="27636"/>
+          <ac:spMkLst>
+            <pc:docMk/>
+            <pc:sldMk cId="2561402868" sldId="264"/>
+            <ac:spMk id="9" creationId="{D6D36DC8-D9BF-8C26-69EA-ED89E34DB644}"/>
+          </ac:spMkLst>
+        </pc:spChg>
+        <pc:graphicFrameChg chg="mod modGraphic">
+          <ac:chgData name="Margo Bonal" userId="18c9fa0f-b53d-478b-9dc0-6ad88786c19f" providerId="ADAL" clId="{93D479E5-F67F-4B8A-A78F-A0B574A116B6}" dt="2026-03-21T14:21:54.477" v="931" actId="20577"/>
+          <ac:graphicFrameMkLst>
+            <pc:docMk/>
+            <pc:sldMk cId="2561402868" sldId="264"/>
+            <ac:graphicFrameMk id="27" creationId="{D6B93F0B-FEB0-EDAB-CFE1-A57DEFE97FCD}"/>
+          </ac:graphicFrameMkLst>
+        </pc:graphicFrameChg>
+      </pc:sldChg>
+      <pc:sldChg chg="delSp modSp mod">
+        <pc:chgData name="Margo Bonal" userId="18c9fa0f-b53d-478b-9dc0-6ad88786c19f" providerId="ADAL" clId="{93D479E5-F67F-4B8A-A78F-A0B574A116B6}" dt="2026-03-30T01:10:14.587" v="969" actId="14100"/>
+        <pc:sldMkLst>
+          <pc:docMk/>
+          <pc:sldMk cId="2428741132" sldId="265"/>
+        </pc:sldMkLst>
+        <pc:spChg chg="mod">
+          <ac:chgData name="Margo Bonal" userId="18c9fa0f-b53d-478b-9dc0-6ad88786c19f" providerId="ADAL" clId="{93D479E5-F67F-4B8A-A78F-A0B574A116B6}" dt="2026-03-30T01:10:14.587" v="969" actId="14100"/>
+          <ac:spMkLst>
+            <pc:docMk/>
+            <pc:sldMk cId="2428741132" sldId="265"/>
+            <ac:spMk id="8" creationId="{7A067979-B2B3-BD33-28AB-42AF2BBE1977}"/>
+          </ac:spMkLst>
+        </pc:spChg>
+      </pc:sldChg>
+      <pc:sldChg chg="modSp mod">
+        <pc:chgData name="Margo Bonal" userId="18c9fa0f-b53d-478b-9dc0-6ad88786c19f" providerId="ADAL" clId="{93D479E5-F67F-4B8A-A78F-A0B574A116B6}" dt="2026-03-21T14:09:48.188" v="518" actId="20577"/>
+        <pc:sldMkLst>
+          <pc:docMk/>
+          <pc:sldMk cId="3526335932" sldId="266"/>
+        </pc:sldMkLst>
+        <pc:spChg chg="mod">
+          <ac:chgData name="Margo Bonal" userId="18c9fa0f-b53d-478b-9dc0-6ad88786c19f" providerId="ADAL" clId="{93D479E5-F67F-4B8A-A78F-A0B574A116B6}" dt="2026-03-21T14:09:48.188" v="518" actId="20577"/>
+          <ac:spMkLst>
+            <pc:docMk/>
+            <pc:sldMk cId="3526335932" sldId="266"/>
+            <ac:spMk id="3" creationId="{CCDEAB36-867D-95B6-8834-F42C5B9259D0}"/>
+          </ac:spMkLst>
+        </pc:spChg>
+        <pc:spChg chg="mod">
+          <ac:chgData name="Margo Bonal" userId="18c9fa0f-b53d-478b-9dc0-6ad88786c19f" providerId="ADAL" clId="{93D479E5-F67F-4B8A-A78F-A0B574A116B6}" dt="2026-03-21T14:09:45.490" v="517" actId="20577"/>
+          <ac:spMkLst>
+            <pc:docMk/>
+            <pc:sldMk cId="3526335932" sldId="266"/>
+            <ac:spMk id="4" creationId="{86ED9EE4-56A8-6AFD-BE9A-A35D2ABC59A0}"/>
+          </ac:spMkLst>
+        </pc:spChg>
+      </pc:sldChg>
+      <pc:sldChg chg="addSp delSp modSp new mod setBg modAnim">
+        <pc:chgData name="Margo Bonal" userId="18c9fa0f-b53d-478b-9dc0-6ad88786c19f" providerId="ADAL" clId="{93D479E5-F67F-4B8A-A78F-A0B574A116B6}" dt="2026-03-30T01:09:55.841" v="967"/>
+        <pc:sldMkLst>
+          <pc:docMk/>
+          <pc:sldMk cId="2282075488" sldId="272"/>
+        </pc:sldMkLst>
+        <pc:spChg chg="mod">
+          <ac:chgData name="Margo Bonal" userId="18c9fa0f-b53d-478b-9dc0-6ad88786c19f" providerId="ADAL" clId="{93D479E5-F67F-4B8A-A78F-A0B574A116B6}" dt="2026-03-30T01:09:17.696" v="964" actId="1076"/>
+          <ac:spMkLst>
+            <pc:docMk/>
+            <pc:sldMk cId="2282075488" sldId="272"/>
+            <ac:spMk id="2" creationId="{C074B1A4-0C15-D874-CBCA-1FB85D3E881D}"/>
+          </ac:spMkLst>
+        </pc:spChg>
+        <pc:spChg chg="del mod">
+          <ac:chgData name="Margo Bonal" userId="18c9fa0f-b53d-478b-9dc0-6ad88786c19f" providerId="ADAL" clId="{93D479E5-F67F-4B8A-A78F-A0B574A116B6}" dt="2026-03-30T01:09:10.546" v="962" actId="478"/>
+          <ac:spMkLst>
+            <pc:docMk/>
+            <pc:sldMk cId="2282075488" sldId="272"/>
+            <ac:spMk id="3" creationId="{F4E85839-AE79-1611-C032-A927048C8D32}"/>
+          </ac:spMkLst>
+        </pc:spChg>
+        <pc:spChg chg="add">
+          <ac:chgData name="Margo Bonal" userId="18c9fa0f-b53d-478b-9dc0-6ad88786c19f" providerId="ADAL" clId="{93D479E5-F67F-4B8A-A78F-A0B574A116B6}" dt="2026-03-30T01:08:59.596" v="958" actId="26606"/>
+          <ac:spMkLst>
+            <pc:docMk/>
+            <pc:sldMk cId="2282075488" sldId="272"/>
+            <ac:spMk id="9" creationId="{A8384FB5-9ADC-4DDC-881B-597D56F5B15D}"/>
+          </ac:spMkLst>
+        </pc:spChg>
+        <pc:spChg chg="add">
+          <ac:chgData name="Margo Bonal" userId="18c9fa0f-b53d-478b-9dc0-6ad88786c19f" providerId="ADAL" clId="{93D479E5-F67F-4B8A-A78F-A0B574A116B6}" dt="2026-03-30T01:08:59.596" v="958" actId="26606"/>
+          <ac:spMkLst>
+            <pc:docMk/>
+            <pc:sldMk cId="2282075488" sldId="272"/>
+            <ac:spMk id="11" creationId="{1199E1B1-A8C0-4FE8-A5A8-1CB41D69F857}"/>
+          </ac:spMkLst>
+        </pc:spChg>
+        <pc:spChg chg="add">
+          <ac:chgData name="Margo Bonal" userId="18c9fa0f-b53d-478b-9dc0-6ad88786c19f" providerId="ADAL" clId="{93D479E5-F67F-4B8A-A78F-A0B574A116B6}" dt="2026-03-30T01:08:59.596" v="958" actId="26606"/>
+          <ac:spMkLst>
+            <pc:docMk/>
+            <pc:sldMk cId="2282075488" sldId="272"/>
+            <ac:spMk id="13" creationId="{84A8DE83-DE75-4B41-9DB4-A7EC0B0DEC0B}"/>
+          </ac:spMkLst>
+        </pc:spChg>
+        <pc:spChg chg="add">
+          <ac:chgData name="Margo Bonal" userId="18c9fa0f-b53d-478b-9dc0-6ad88786c19f" providerId="ADAL" clId="{93D479E5-F67F-4B8A-A78F-A0B574A116B6}" dt="2026-03-30T01:08:59.596" v="958" actId="26606"/>
+          <ac:spMkLst>
+            <pc:docMk/>
+            <pc:sldMk cId="2282075488" sldId="272"/>
+            <ac:spMk id="15" creationId="{A7009A0A-BEF5-4EAC-AF15-E4F9F002E239}"/>
+          </ac:spMkLst>
+        </pc:spChg>
+        <pc:picChg chg="add del mod">
+          <ac:chgData name="Margo Bonal" userId="18c9fa0f-b53d-478b-9dc0-6ad88786c19f" providerId="ADAL" clId="{93D479E5-F67F-4B8A-A78F-A0B574A116B6}" dt="2026-03-30T01:09:31.322" v="966" actId="478"/>
+          <ac:picMkLst>
+            <pc:docMk/>
+            <pc:sldMk cId="2282075488" sldId="272"/>
+            <ac:picMk id="4" creationId="{4F012FE5-91F7-BF57-0376-41BC4711BDEB}"/>
+          </ac:picMkLst>
+        </pc:picChg>
+        <pc:picChg chg="add mod">
+          <ac:chgData name="Margo Bonal" userId="18c9fa0f-b53d-478b-9dc0-6ad88786c19f" providerId="ADAL" clId="{93D479E5-F67F-4B8A-A78F-A0B574A116B6}" dt="2026-03-30T01:09:55.841" v="967"/>
+          <ac:picMkLst>
+            <pc:docMk/>
+            <pc:sldMk cId="2282075488" sldId="272"/>
+            <ac:picMk id="5" creationId="{AD0A49AD-572F-1BD3-B96A-4F6CEBD54DC1}"/>
+          </ac:picMkLst>
+        </pc:picChg>
+      </pc:sldChg>
+    </pc:docChg>
+  </pc:docChgLst>
+  <pc:docChgLst>
     <pc:chgData name="Margo Bonal" userId="18c9fa0f-b53d-478b-9dc0-6ad88786c19f" providerId="ADAL" clId="{57E2D5E0-CA32-47BE-A2DC-7B0365E99328}"/>
     <pc:docChg chg="undo custSel addSld delSld modSld sldOrd">
       <pc:chgData name="Margo Bonal" userId="18c9fa0f-b53d-478b-9dc0-6ad88786c19f" providerId="ADAL" clId="{57E2D5E0-CA32-47BE-A2DC-7B0365E99328}" dt="2026-03-28T15:16:48.747" v="374" actId="9405"/>
@@ -322,14 +402,6 @@
           <pc:docMk/>
           <pc:sldMk cId="2428741132" sldId="265"/>
         </pc:sldMkLst>
-        <pc:spChg chg="del mod">
-          <ac:chgData name="Margo Bonal" userId="18c9fa0f-b53d-478b-9dc0-6ad88786c19f" providerId="ADAL" clId="{57E2D5E0-CA32-47BE-A2DC-7B0365E99328}" dt="2026-03-28T13:35:09.010" v="152"/>
-          <ac:spMkLst>
-            <pc:docMk/>
-            <pc:sldMk cId="2428741132" sldId="265"/>
-            <ac:spMk id="5" creationId="{96580BFF-A19E-F65F-2069-5D219B5DF38E}"/>
-          </ac:spMkLst>
-        </pc:spChg>
         <pc:spChg chg="mod">
           <ac:chgData name="Margo Bonal" userId="18c9fa0f-b53d-478b-9dc0-6ad88786c19f" providerId="ADAL" clId="{57E2D5E0-CA32-47BE-A2DC-7B0365E99328}" dt="2026-03-28T15:12:52.323" v="352" actId="20577"/>
           <ac:spMkLst>
@@ -368,30 +440,6 @@
           <pc:docMk/>
           <pc:sldMk cId="2137746370" sldId="267"/>
         </pc:sldMkLst>
-        <pc:spChg chg="del">
-          <ac:chgData name="Margo Bonal" userId="18c9fa0f-b53d-478b-9dc0-6ad88786c19f" providerId="ADAL" clId="{57E2D5E0-CA32-47BE-A2DC-7B0365E99328}" dt="2026-03-28T15:01:05.923" v="168" actId="478"/>
-          <ac:spMkLst>
-            <pc:docMk/>
-            <pc:sldMk cId="2137746370" sldId="267"/>
-            <ac:spMk id="2" creationId="{B29B8A9D-B81E-6521-9EC4-948FB52430BC}"/>
-          </ac:spMkLst>
-        </pc:spChg>
-        <pc:spChg chg="del">
-          <ac:chgData name="Margo Bonal" userId="18c9fa0f-b53d-478b-9dc0-6ad88786c19f" providerId="ADAL" clId="{57E2D5E0-CA32-47BE-A2DC-7B0365E99328}" dt="2026-03-28T15:01:07.551" v="169" actId="478"/>
-          <ac:spMkLst>
-            <pc:docMk/>
-            <pc:sldMk cId="2137746370" sldId="267"/>
-            <ac:spMk id="3" creationId="{EF712E20-015F-A1CE-5E80-D58CF1D3E50F}"/>
-          </ac:spMkLst>
-        </pc:spChg>
-        <pc:spChg chg="add">
-          <ac:chgData name="Margo Bonal" userId="18c9fa0f-b53d-478b-9dc0-6ad88786c19f" providerId="ADAL" clId="{57E2D5E0-CA32-47BE-A2DC-7B0365E99328}" dt="2026-03-28T15:01:08.228" v="170"/>
-          <ac:spMkLst>
-            <pc:docMk/>
-            <pc:sldMk cId="2137746370" sldId="267"/>
-            <ac:spMk id="4" creationId="{C05ECE52-0CF3-DE79-7C8C-B9F9D9C0C728}"/>
-          </ac:spMkLst>
-        </pc:spChg>
         <pc:picChg chg="add mod">
           <ac:chgData name="Margo Bonal" userId="18c9fa0f-b53d-478b-9dc0-6ad88786c19f" providerId="ADAL" clId="{57E2D5E0-CA32-47BE-A2DC-7B0365E99328}" dt="2026-03-28T15:02:49.042" v="174" actId="14100"/>
           <ac:picMkLst>
@@ -407,22 +455,6 @@
           <pc:docMk/>
           <pc:sldMk cId="522380866" sldId="268"/>
         </pc:sldMkLst>
-        <pc:spChg chg="del">
-          <ac:chgData name="Margo Bonal" userId="18c9fa0f-b53d-478b-9dc0-6ad88786c19f" providerId="ADAL" clId="{57E2D5E0-CA32-47BE-A2DC-7B0365E99328}" dt="2026-03-28T15:12:57.860" v="354" actId="478"/>
-          <ac:spMkLst>
-            <pc:docMk/>
-            <pc:sldMk cId="522380866" sldId="268"/>
-            <ac:spMk id="2" creationId="{1BE9333E-5D88-14C0-2B17-EB2969EF5F4F}"/>
-          </ac:spMkLst>
-        </pc:spChg>
-        <pc:spChg chg="del">
-          <ac:chgData name="Margo Bonal" userId="18c9fa0f-b53d-478b-9dc0-6ad88786c19f" providerId="ADAL" clId="{57E2D5E0-CA32-47BE-A2DC-7B0365E99328}" dt="2026-03-28T15:12:59.298" v="355" actId="478"/>
-          <ac:spMkLst>
-            <pc:docMk/>
-            <pc:sldMk cId="522380866" sldId="268"/>
-            <ac:spMk id="3" creationId="{7C381C7C-B7D1-1CFD-EA81-85663522CAF4}"/>
-          </ac:spMkLst>
-        </pc:spChg>
         <pc:picChg chg="add mod">
           <ac:chgData name="Margo Bonal" userId="18c9fa0f-b53d-478b-9dc0-6ad88786c19f" providerId="ADAL" clId="{57E2D5E0-CA32-47BE-A2DC-7B0365E99328}" dt="2026-03-28T15:15:32.474" v="367" actId="14100"/>
           <ac:picMkLst>
@@ -454,22 +486,6 @@
           <pc:docMk/>
           <pc:sldMk cId="405284316" sldId="269"/>
         </pc:sldMkLst>
-        <pc:spChg chg="del">
-          <ac:chgData name="Margo Bonal" userId="18c9fa0f-b53d-478b-9dc0-6ad88786c19f" providerId="ADAL" clId="{57E2D5E0-CA32-47BE-A2DC-7B0365E99328}" dt="2026-03-28T15:15:14.763" v="361" actId="21"/>
-          <ac:spMkLst>
-            <pc:docMk/>
-            <pc:sldMk cId="405284316" sldId="269"/>
-            <ac:spMk id="2" creationId="{05B4D920-ABA2-0F89-FDCF-DCE3AEA3267B}"/>
-          </ac:spMkLst>
-        </pc:spChg>
-        <pc:spChg chg="del">
-          <ac:chgData name="Margo Bonal" userId="18c9fa0f-b53d-478b-9dc0-6ad88786c19f" providerId="ADAL" clId="{57E2D5E0-CA32-47BE-A2DC-7B0365E99328}" dt="2026-03-28T15:15:18.662" v="362" actId="21"/>
-          <ac:spMkLst>
-            <pc:docMk/>
-            <pc:sldMk cId="405284316" sldId="269"/>
-            <ac:spMk id="3" creationId="{24BA0364-FB32-0428-2B5D-D109DAC8FEF3}"/>
-          </ac:spMkLst>
-        </pc:spChg>
         <pc:picChg chg="add mod">
           <ac:chgData name="Margo Bonal" userId="18c9fa0f-b53d-478b-9dc0-6ad88786c19f" providerId="ADAL" clId="{57E2D5E0-CA32-47BE-A2DC-7B0365E99328}" dt="2026-03-28T15:15:27.255" v="365" actId="14100"/>
           <ac:picMkLst>
@@ -486,41 +502,6 @@
             <ac:inkMk id="6" creationId="{C7D73243-445E-0B04-A779-41352EFCFB99}"/>
           </ac:inkMkLst>
         </pc:inkChg>
-      </pc:sldChg>
-      <pc:sldChg chg="del">
-        <pc:chgData name="Margo Bonal" userId="18c9fa0f-b53d-478b-9dc0-6ad88786c19f" providerId="ADAL" clId="{57E2D5E0-CA32-47BE-A2DC-7B0365E99328}" dt="2026-03-28T13:35:20.157" v="156" actId="2696"/>
-        <pc:sldMkLst>
-          <pc:docMk/>
-          <pc:sldMk cId="1174568043" sldId="273"/>
-        </pc:sldMkLst>
-      </pc:sldChg>
-      <pc:sldChg chg="del">
-        <pc:chgData name="Margo Bonal" userId="18c9fa0f-b53d-478b-9dc0-6ad88786c19f" providerId="ADAL" clId="{57E2D5E0-CA32-47BE-A2DC-7B0365E99328}" dt="2026-03-28T13:35:23.800" v="158" actId="2696"/>
-        <pc:sldMkLst>
-          <pc:docMk/>
-          <pc:sldMk cId="4091789368" sldId="274"/>
-        </pc:sldMkLst>
-      </pc:sldChg>
-      <pc:sldChg chg="del">
-        <pc:chgData name="Margo Bonal" userId="18c9fa0f-b53d-478b-9dc0-6ad88786c19f" providerId="ADAL" clId="{57E2D5E0-CA32-47BE-A2DC-7B0365E99328}" dt="2026-03-28T13:35:17.878" v="155" actId="2696"/>
-        <pc:sldMkLst>
-          <pc:docMk/>
-          <pc:sldMk cId="587209447" sldId="279"/>
-        </pc:sldMkLst>
-      </pc:sldChg>
-      <pc:sldChg chg="del">
-        <pc:chgData name="Margo Bonal" userId="18c9fa0f-b53d-478b-9dc0-6ad88786c19f" providerId="ADAL" clId="{57E2D5E0-CA32-47BE-A2DC-7B0365E99328}" dt="2026-03-28T13:35:25.723" v="159" actId="2696"/>
-        <pc:sldMkLst>
-          <pc:docMk/>
-          <pc:sldMk cId="408115139" sldId="280"/>
-        </pc:sldMkLst>
-      </pc:sldChg>
-      <pc:sldChg chg="del">
-        <pc:chgData name="Margo Bonal" userId="18c9fa0f-b53d-478b-9dc0-6ad88786c19f" providerId="ADAL" clId="{57E2D5E0-CA32-47BE-A2DC-7B0365E99328}" dt="2026-03-28T13:35:22.046" v="157" actId="2696"/>
-        <pc:sldMkLst>
-          <pc:docMk/>
-          <pc:sldMk cId="3181737189" sldId="281"/>
-        </pc:sldMkLst>
       </pc:sldChg>
     </pc:docChg>
   </pc:docChgLst>
@@ -10362,6 +10343,562 @@
     </p:bg>
     <p:spTree>
       <p:nvGrpSpPr>
+        <p:cNvPr id="1" name=""/>
+        <p:cNvGrpSpPr/>
+        <p:nvPr/>
+      </p:nvGrpSpPr>
+      <p:grpSpPr>
+        <a:xfrm>
+          <a:off x="0" y="0"/>
+          <a:ext cx="0" cy="0"/>
+          <a:chOff x="0" y="0"/>
+          <a:chExt cx="0" cy="0"/>
+        </a:xfrm>
+      </p:grpSpPr>
+      <p:sp useBgFill="1">
+        <p:nvSpPr>
+          <p:cNvPr id="9" name="Rectangle 8">
+            <a:extLst>
+              <a:ext uri="{FF2B5EF4-FFF2-40B4-BE49-F238E27FC236}">
+                <a16:creationId xmlns:a16="http://schemas.microsoft.com/office/drawing/2014/main" id="{A8384FB5-9ADC-4DDC-881B-597D56F5B15D}"/>
+              </a:ext>
+              <a:ext uri="{C183D7F6-B498-43B3-948B-1728B52AA6E4}">
+                <adec:decorative xmlns:adec="http://schemas.microsoft.com/office/drawing/2017/decorative" val="1"/>
+              </a:ext>
+            </a:extLst>
+          </p:cNvPr>
+          <p:cNvSpPr>
+            <a:spLocks noGrp="1" noRot="1" noChangeAspect="1" noMove="1" noResize="1" noEditPoints="1" noAdjustHandles="1" noChangeArrowheads="1" noChangeShapeType="1" noTextEdit="1"/>
+          </p:cNvSpPr>
+          <p:nvPr>
+            <p:extLst>
+              <p:ext uri="{386F3935-93C4-4BCD-93E2-E3B085C9AB24}">
+                <p16:designElem xmlns:p16="http://schemas.microsoft.com/office/powerpoint/2015/main" val="1"/>
+              </p:ext>
+            </p:extLst>
+          </p:nvPr>
+        </p:nvSpPr>
+        <p:spPr>
+          <a:xfrm>
+            <a:off x="0" y="0"/>
+            <a:ext cx="12192000" cy="6858000"/>
+          </a:xfrm>
+          <a:prstGeom prst="rect">
+            <a:avLst/>
+          </a:prstGeom>
+          <a:ln w="12700" cap="flat" cmpd="sng" algn="ctr">
+            <a:noFill/>
+            <a:prstDash val="solid"/>
+            <a:miter lim="800000"/>
+          </a:ln>
+          <a:effectLst/>
+          <a:extLst>
+            <a:ext uri="{91240B29-F687-4F45-9708-019B960494DF}">
+              <a14:hiddenLine xmlns:a14="http://schemas.microsoft.com/office/drawing/2010/main" w="12700" cap="flat" cmpd="sng" algn="ctr">
+                <a:solidFill>
+                  <a:schemeClr val="accent1">
+                    <a:shade val="50000"/>
+                  </a:schemeClr>
+                </a:solidFill>
+                <a:prstDash val="solid"/>
+                <a:miter lim="800000"/>
+              </a14:hiddenLine>
+            </a:ext>
+          </a:extLst>
+        </p:spPr>
+        <p:style>
+          <a:lnRef idx="2">
+            <a:schemeClr val="accent1">
+              <a:shade val="50000"/>
+            </a:schemeClr>
+          </a:lnRef>
+          <a:fillRef idx="1">
+            <a:schemeClr val="accent1"/>
+          </a:fillRef>
+          <a:effectRef idx="0">
+            <a:schemeClr val="accent1"/>
+          </a:effectRef>
+          <a:fontRef idx="minor">
+            <a:schemeClr val="lt1"/>
+          </a:fontRef>
+        </p:style>
+        <p:txBody>
+          <a:bodyPr rtlCol="0" anchor="ctr"/>
+          <a:lstStyle/>
+          <a:p>
+            <a:pPr algn="ctr"/>
+            <a:endParaRPr lang="en-US"/>
+          </a:p>
+        </p:txBody>
+      </p:sp>
+      <p:sp>
+        <p:nvSpPr>
+          <p:cNvPr id="11" name="Rectangle 10">
+            <a:extLst>
+              <a:ext uri="{FF2B5EF4-FFF2-40B4-BE49-F238E27FC236}">
+                <a16:creationId xmlns:a16="http://schemas.microsoft.com/office/drawing/2014/main" id="{1199E1B1-A8C0-4FE8-A5A8-1CB41D69F857}"/>
+              </a:ext>
+              <a:ext uri="{C183D7F6-B498-43B3-948B-1728B52AA6E4}">
+                <adec:decorative xmlns:adec="http://schemas.microsoft.com/office/drawing/2017/decorative" val="1"/>
+              </a:ext>
+            </a:extLst>
+          </p:cNvPr>
+          <p:cNvSpPr>
+            <a:spLocks noGrp="1" noRot="1" noChangeAspect="1" noMove="1" noResize="1" noEditPoints="1" noAdjustHandles="1" noChangeArrowheads="1" noChangeShapeType="1" noTextEdit="1"/>
+          </p:cNvSpPr>
+          <p:nvPr>
+            <p:extLst>
+              <p:ext uri="{386F3935-93C4-4BCD-93E2-E3B085C9AB24}">
+                <p16:designElem xmlns:p16="http://schemas.microsoft.com/office/powerpoint/2015/main" val="1"/>
+              </p:ext>
+            </p:extLst>
+          </p:nvPr>
+        </p:nvSpPr>
+        <p:spPr>
+          <a:xfrm rot="10800000" flipH="1">
+            <a:off x="2" y="0"/>
+            <a:ext cx="12191998" cy="1575955"/>
+          </a:xfrm>
+          <a:prstGeom prst="rect">
+            <a:avLst/>
+          </a:prstGeom>
+          <a:gradFill>
+            <a:gsLst>
+              <a:gs pos="0">
+                <a:srgbClr val="000000">
+                  <a:alpha val="96000"/>
+                </a:srgbClr>
+              </a:gs>
+              <a:gs pos="100000">
+                <a:schemeClr val="accent1">
+                  <a:lumMod val="75000"/>
+                </a:schemeClr>
+              </a:gs>
+            </a:gsLst>
+            <a:lin ang="6000000" scaled="0"/>
+          </a:gradFill>
+          <a:ln>
+            <a:noFill/>
+          </a:ln>
+        </p:spPr>
+        <p:style>
+          <a:lnRef idx="2">
+            <a:schemeClr val="accent1">
+              <a:shade val="50000"/>
+            </a:schemeClr>
+          </a:lnRef>
+          <a:fillRef idx="1">
+            <a:schemeClr val="accent1"/>
+          </a:fillRef>
+          <a:effectRef idx="0">
+            <a:schemeClr val="accent1"/>
+          </a:effectRef>
+          <a:fontRef idx="minor">
+            <a:schemeClr val="lt1"/>
+          </a:fontRef>
+        </p:style>
+        <p:txBody>
+          <a:bodyPr rtlCol="0" anchor="ctr"/>
+          <a:lstStyle/>
+          <a:p>
+            <a:pPr algn="ctr"/>
+            <a:endParaRPr lang="en-US"/>
+          </a:p>
+        </p:txBody>
+      </p:sp>
+      <p:sp>
+        <p:nvSpPr>
+          <p:cNvPr id="13" name="Rectangle 12">
+            <a:extLst>
+              <a:ext uri="{FF2B5EF4-FFF2-40B4-BE49-F238E27FC236}">
+                <a16:creationId xmlns:a16="http://schemas.microsoft.com/office/drawing/2014/main" id="{84A8DE83-DE75-4B41-9DB4-A7EC0B0DEC0B}"/>
+              </a:ext>
+              <a:ext uri="{C183D7F6-B498-43B3-948B-1728B52AA6E4}">
+                <adec:decorative xmlns:adec="http://schemas.microsoft.com/office/drawing/2017/decorative" val="1"/>
+              </a:ext>
+            </a:extLst>
+          </p:cNvPr>
+          <p:cNvSpPr>
+            <a:spLocks noGrp="1" noRot="1" noChangeAspect="1" noMove="1" noResize="1" noEditPoints="1" noAdjustHandles="1" noChangeArrowheads="1" noChangeShapeType="1" noTextEdit="1"/>
+          </p:cNvSpPr>
+          <p:nvPr>
+            <p:extLst>
+              <p:ext uri="{386F3935-93C4-4BCD-93E2-E3B085C9AB24}">
+                <p16:designElem xmlns:p16="http://schemas.microsoft.com/office/powerpoint/2015/main" val="1"/>
+              </p:ext>
+            </p:extLst>
+          </p:nvPr>
+        </p:nvSpPr>
+        <p:spPr>
+          <a:xfrm>
+            <a:off x="0" y="0"/>
+            <a:ext cx="8128856" cy="1575461"/>
+          </a:xfrm>
+          <a:prstGeom prst="rect">
+            <a:avLst/>
+          </a:prstGeom>
+          <a:gradFill>
+            <a:gsLst>
+              <a:gs pos="0">
+                <a:schemeClr val="accent1">
+                  <a:alpha val="41000"/>
+                </a:schemeClr>
+              </a:gs>
+              <a:gs pos="74000">
+                <a:schemeClr val="accent1">
+                  <a:lumMod val="60000"/>
+                  <a:lumOff val="40000"/>
+                  <a:alpha val="0"/>
+                </a:schemeClr>
+              </a:gs>
+            </a:gsLst>
+            <a:lin ang="8400000" scaled="0"/>
+          </a:gradFill>
+          <a:ln>
+            <a:noFill/>
+          </a:ln>
+        </p:spPr>
+        <p:style>
+          <a:lnRef idx="2">
+            <a:schemeClr val="accent1">
+              <a:shade val="50000"/>
+            </a:schemeClr>
+          </a:lnRef>
+          <a:fillRef idx="1">
+            <a:schemeClr val="accent1"/>
+          </a:fillRef>
+          <a:effectRef idx="0">
+            <a:schemeClr val="accent1"/>
+          </a:effectRef>
+          <a:fontRef idx="minor">
+            <a:schemeClr val="lt1"/>
+          </a:fontRef>
+        </p:style>
+        <p:txBody>
+          <a:bodyPr rtlCol="0" anchor="ctr"/>
+          <a:lstStyle/>
+          <a:p>
+            <a:pPr algn="ctr"/>
+            <a:endParaRPr lang="en-US"/>
+          </a:p>
+        </p:txBody>
+      </p:sp>
+      <p:sp>
+        <p:nvSpPr>
+          <p:cNvPr id="15" name="Rectangle 14">
+            <a:extLst>
+              <a:ext uri="{FF2B5EF4-FFF2-40B4-BE49-F238E27FC236}">
+                <a16:creationId xmlns:a16="http://schemas.microsoft.com/office/drawing/2014/main" id="{A7009A0A-BEF5-4EAC-AF15-E4F9F002E239}"/>
+              </a:ext>
+              <a:ext uri="{C183D7F6-B498-43B3-948B-1728B52AA6E4}">
+                <adec:decorative xmlns:adec="http://schemas.microsoft.com/office/drawing/2017/decorative" val="1"/>
+              </a:ext>
+            </a:extLst>
+          </p:cNvPr>
+          <p:cNvSpPr>
+            <a:spLocks noGrp="1" noRot="1" noChangeAspect="1" noMove="1" noResize="1" noEditPoints="1" noAdjustHandles="1" noChangeArrowheads="1" noChangeShapeType="1" noTextEdit="1"/>
+          </p:cNvSpPr>
+          <p:nvPr>
+            <p:extLst>
+              <p:ext uri="{386F3935-93C4-4BCD-93E2-E3B085C9AB24}">
+                <p16:designElem xmlns:p16="http://schemas.microsoft.com/office/powerpoint/2015/main" val="1"/>
+              </p:ext>
+            </p:extLst>
+          </p:nvPr>
+        </p:nvSpPr>
+        <p:spPr>
+          <a:xfrm flipH="1">
+            <a:off x="-3" y="-1"/>
+            <a:ext cx="12192002" cy="1574311"/>
+          </a:xfrm>
+          <a:prstGeom prst="rect">
+            <a:avLst/>
+          </a:prstGeom>
+          <a:gradFill>
+            <a:gsLst>
+              <a:gs pos="0">
+                <a:srgbClr val="000000">
+                  <a:alpha val="63000"/>
+                </a:srgbClr>
+              </a:gs>
+              <a:gs pos="78000">
+                <a:schemeClr val="accent1">
+                  <a:alpha val="15000"/>
+                </a:schemeClr>
+              </a:gs>
+            </a:gsLst>
+            <a:lin ang="15600000" scaled="0"/>
+          </a:gradFill>
+          <a:ln>
+            <a:noFill/>
+          </a:ln>
+        </p:spPr>
+        <p:style>
+          <a:lnRef idx="2">
+            <a:schemeClr val="accent1">
+              <a:shade val="50000"/>
+            </a:schemeClr>
+          </a:lnRef>
+          <a:fillRef idx="1">
+            <a:schemeClr val="accent1"/>
+          </a:fillRef>
+          <a:effectRef idx="0">
+            <a:schemeClr val="accent1"/>
+          </a:effectRef>
+          <a:fontRef idx="minor">
+            <a:schemeClr val="lt1"/>
+          </a:fontRef>
+        </p:style>
+        <p:txBody>
+          <a:bodyPr rtlCol="0" anchor="ctr"/>
+          <a:lstStyle/>
+          <a:p>
+            <a:pPr algn="ctr"/>
+            <a:endParaRPr lang="en-US"/>
+          </a:p>
+        </p:txBody>
+      </p:sp>
+      <p:sp>
+        <p:nvSpPr>
+          <p:cNvPr id="2" name="Title 1">
+            <a:extLst>
+              <a:ext uri="{FF2B5EF4-FFF2-40B4-BE49-F238E27FC236}">
+                <a16:creationId xmlns:a16="http://schemas.microsoft.com/office/drawing/2014/main" id="{C074B1A4-0C15-D874-CBCA-1FB85D3E881D}"/>
+              </a:ext>
+            </a:extLst>
+          </p:cNvPr>
+          <p:cNvSpPr>
+            <a:spLocks noGrp="1"/>
+          </p:cNvSpPr>
+          <p:nvPr>
+            <p:ph type="title"/>
+          </p:nvPr>
+        </p:nvSpPr>
+        <p:spPr>
+          <a:xfrm>
+            <a:off x="4272534" y="84536"/>
+            <a:ext cx="3278835" cy="1159200"/>
+          </a:xfrm>
+        </p:spPr>
+        <p:txBody>
+          <a:bodyPr vert="horz" lIns="91440" tIns="45720" rIns="91440" bIns="45720" rtlCol="0" anchor="ctr">
+            <a:normAutofit/>
+          </a:bodyPr>
+          <a:lstStyle/>
+          <a:p>
+            <a:r>
+              <a:rPr lang="en-US" sz="4000" kern="1200" dirty="0">
+                <a:solidFill>
+                  <a:srgbClr val="FFFFFF"/>
+                </a:solidFill>
+                <a:latin typeface="+mj-lt"/>
+                <a:ea typeface="+mj-ea"/>
+                <a:cs typeface="+mj-cs"/>
+              </a:rPr>
+              <a:t>Teams Page</a:t>
+            </a:r>
+          </a:p>
+        </p:txBody>
+      </p:sp>
+      <p:pic>
+        <p:nvPicPr>
+          <p:cNvPr id="5" name="TeamsPageCoach">
+            <a:hlinkClick r:id="" action="ppaction://media"/>
+            <a:extLst>
+              <a:ext uri="{FF2B5EF4-FFF2-40B4-BE49-F238E27FC236}">
+                <a16:creationId xmlns:a16="http://schemas.microsoft.com/office/drawing/2014/main" id="{AD0A49AD-572F-1BD3-B96A-4F6CEBD54DC1}"/>
+              </a:ext>
+            </a:extLst>
+          </p:cNvPr>
+          <p:cNvPicPr>
+            <a:picLocks noChangeAspect="1"/>
+          </p:cNvPicPr>
+          <p:nvPr>
+            <a:videoFile r:link="rId2"/>
+            <p:extLst>
+              <p:ext uri="{DAA4B4D4-6D71-4841-9C94-3DE7FCFB9230}">
+                <p14:media xmlns:p14="http://schemas.microsoft.com/office/powerpoint/2010/main" r:embed="rId1"/>
+              </p:ext>
+            </p:extLst>
+          </p:nvPr>
+        </p:nvPicPr>
+        <p:blipFill>
+          <a:blip r:embed="rId4"/>
+          <a:stretch>
+            <a:fillRect/>
+          </a:stretch>
+        </p:blipFill>
+        <p:spPr>
+          <a:xfrm>
+            <a:off x="-4" y="1574310"/>
+            <a:ext cx="12191998" cy="5367226"/>
+          </a:xfrm>
+          <a:prstGeom prst="rect">
+            <a:avLst/>
+          </a:prstGeom>
+        </p:spPr>
+      </p:pic>
+    </p:spTree>
+    <p:extLst>
+      <p:ext uri="{BB962C8B-B14F-4D97-AF65-F5344CB8AC3E}">
+        <p14:creationId xmlns:p14="http://schemas.microsoft.com/office/powerpoint/2010/main" val="2282075488"/>
+      </p:ext>
+    </p:extLst>
+  </p:cSld>
+  <p:clrMapOvr>
+    <a:masterClrMapping/>
+  </p:clrMapOvr>
+  <p:timing>
+    <p:tnLst>
+      <p:par>
+        <p:cTn id="1" dur="indefinite" restart="never" nodeType="tmRoot">
+          <p:childTnLst>
+            <p:seq concurrent="1" nextAc="seek">
+              <p:cTn id="2" dur="indefinite" nodeType="mainSeq">
+                <p:childTnLst>
+                  <p:par>
+                    <p:cTn id="3" fill="hold">
+                      <p:stCondLst>
+                        <p:cond delay="indefinite"/>
+                      </p:stCondLst>
+                      <p:childTnLst>
+                        <p:par>
+                          <p:cTn id="4" fill="hold">
+                            <p:stCondLst>
+                              <p:cond delay="0"/>
+                            </p:stCondLst>
+                            <p:childTnLst>
+                              <p:par>
+                                <p:cTn id="5" presetID="1" presetClass="mediacall" presetSubtype="0" fill="hold" nodeType="clickEffect">
+                                  <p:stCondLst>
+                                    <p:cond delay="0"/>
+                                  </p:stCondLst>
+                                  <p:childTnLst>
+                                    <p:cmd type="call" cmd="playFrom(0.0)">
+                                      <p:cBhvr>
+                                        <p:cTn id="6" dur="70890" fill="hold"/>
+                                        <p:tgtEl>
+                                          <p:spTgt spid="5"/>
+                                        </p:tgtEl>
+                                      </p:cBhvr>
+                                    </p:cmd>
+                                  </p:childTnLst>
+                                </p:cTn>
+                              </p:par>
+                            </p:childTnLst>
+                          </p:cTn>
+                        </p:par>
+                      </p:childTnLst>
+                    </p:cTn>
+                  </p:par>
+                </p:childTnLst>
+              </p:cTn>
+              <p:prevCondLst>
+                <p:cond evt="onPrev" delay="0">
+                  <p:tgtEl>
+                    <p:sldTgt/>
+                  </p:tgtEl>
+                </p:cond>
+              </p:prevCondLst>
+              <p:nextCondLst>
+                <p:cond evt="onNext" delay="0">
+                  <p:tgtEl>
+                    <p:sldTgt/>
+                  </p:tgtEl>
+                </p:cond>
+              </p:nextCondLst>
+            </p:seq>
+            <p:seq concurrent="1" nextAc="seek">
+              <p:cTn id="7" restart="whenNotActive" fill="hold" evtFilter="cancelBubble" nodeType="interactiveSeq">
+                <p:stCondLst>
+                  <p:cond evt="onClick" delay="0">
+                    <p:tgtEl>
+                      <p:spTgt spid="5"/>
+                    </p:tgtEl>
+                  </p:cond>
+                </p:stCondLst>
+                <p:endSync evt="end" delay="0">
+                  <p:rtn val="all"/>
+                </p:endSync>
+                <p:childTnLst>
+                  <p:par>
+                    <p:cTn id="8" fill="hold">
+                      <p:stCondLst>
+                        <p:cond delay="0"/>
+                      </p:stCondLst>
+                      <p:childTnLst>
+                        <p:par>
+                          <p:cTn id="9" fill="hold">
+                            <p:stCondLst>
+                              <p:cond delay="0"/>
+                            </p:stCondLst>
+                            <p:childTnLst>
+                              <p:par>
+                                <p:cTn id="10" presetID="2" presetClass="mediacall" presetSubtype="0" fill="hold" nodeType="clickEffect">
+                                  <p:stCondLst>
+                                    <p:cond delay="0"/>
+                                  </p:stCondLst>
+                                  <p:childTnLst>
+                                    <p:cmd type="call" cmd="togglePause">
+                                      <p:cBhvr>
+                                        <p:cTn id="11" dur="1" fill="hold"/>
+                                        <p:tgtEl>
+                                          <p:spTgt spid="5"/>
+                                        </p:tgtEl>
+                                      </p:cBhvr>
+                                    </p:cmd>
+                                  </p:childTnLst>
+                                </p:cTn>
+                              </p:par>
+                            </p:childTnLst>
+                          </p:cTn>
+                        </p:par>
+                      </p:childTnLst>
+                    </p:cTn>
+                  </p:par>
+                </p:childTnLst>
+              </p:cTn>
+              <p:nextCondLst>
+                <p:cond evt="onClick" delay="0">
+                  <p:tgtEl>
+                    <p:spTgt spid="5"/>
+                  </p:tgtEl>
+                </p:cond>
+              </p:nextCondLst>
+            </p:seq>
+            <p:video>
+              <p:cMediaNode vol="80000">
+                <p:cTn id="12" fill="hold" display="0">
+                  <p:stCondLst>
+                    <p:cond delay="indefinite"/>
+                  </p:stCondLst>
+                </p:cTn>
+                <p:tgtEl>
+                  <p:spTgt spid="5"/>
+                </p:tgtEl>
+              </p:cMediaNode>
+            </p:video>
+          </p:childTnLst>
+        </p:cTn>
+      </p:par>
+    </p:tnLst>
+  </p:timing>
+</p:sld>
+</file>
+
+<file path=ppt/slides/slide12.xml><?xml version="1.0" encoding="utf-8"?>
+<p:sld xmlns:a="http://schemas.openxmlformats.org/drawingml/2006/main" xmlns:r="http://schemas.openxmlformats.org/officeDocument/2006/relationships" xmlns:p="http://schemas.openxmlformats.org/presentationml/2006/main">
+  <p:cSld>
+    <p:bg>
+      <p:bgPr>
+        <a:solidFill>
+          <a:schemeClr val="bg1"/>
+        </a:solidFill>
+        <a:effectLst/>
+      </p:bgPr>
+    </p:bg>
+    <p:spTree>
+      <p:nvGrpSpPr>
         <p:cNvPr id="1" name="">
           <a:extLst>
             <a:ext uri="{FF2B5EF4-FFF2-40B4-BE49-F238E27FC236}">
@@ -10701,7 +11238,7 @@
 </p:sld>
 </file>
 
-<file path=ppt/slides/slide12.xml><?xml version="1.0" encoding="utf-8"?>
+<file path=ppt/slides/slide13.xml><?xml version="1.0" encoding="utf-8"?>
 <p:sld xmlns:a="http://schemas.openxmlformats.org/drawingml/2006/main" xmlns:r="http://schemas.openxmlformats.org/officeDocument/2006/relationships" xmlns:p="http://schemas.openxmlformats.org/presentationml/2006/main">
   <p:cSld>
     <p:bg>
@@ -11089,7 +11626,7 @@
 </p:sld>
 </file>
 
-<file path=ppt/slides/slide13.xml><?xml version="1.0" encoding="utf-8"?>
+<file path=ppt/slides/slide14.xml><?xml version="1.0" encoding="utf-8"?>
 <p:sld xmlns:a="http://schemas.openxmlformats.org/drawingml/2006/main" xmlns:r="http://schemas.openxmlformats.org/officeDocument/2006/relationships" xmlns:p="http://schemas.openxmlformats.org/presentationml/2006/main">
   <p:cSld>
     <p:bg>
@@ -12218,8 +12755,8 @@
         </p:nvSpPr>
         <p:spPr>
           <a:xfrm>
-            <a:off x="2045432" y="2666571"/>
-            <a:ext cx="8101135" cy="3422064"/>
+            <a:off x="1834856" y="2313250"/>
+            <a:ext cx="8311711" cy="3775385"/>
           </a:xfrm>
           <a:prstGeom prst="rect">
             <a:avLst/>
@@ -12424,7 +12961,11 @@
               <a:buChar char="•"/>
             </a:pPr>
             <a:r>
-              <a:rPr lang="en-US" dirty="0"/>
+              <a:rPr lang="en-US" dirty="0">
+                <a:solidFill>
+                  <a:schemeClr val="tx1"/>
+                </a:solidFill>
+              </a:rPr>
               <a:t>Finish Friends feature data displays</a:t>
             </a:r>
           </a:p>
@@ -12434,7 +12975,11 @@
               <a:buChar char="•"/>
             </a:pPr>
             <a:r>
-              <a:rPr lang="en-US" dirty="0"/>
+              <a:rPr lang="en-US" dirty="0">
+                <a:solidFill>
+                  <a:schemeClr val="tx1"/>
+                </a:solidFill>
+              </a:rPr>
               <a:t>Finish settings page</a:t>
             </a:r>
           </a:p>
@@ -12444,7 +12989,11 @@
               <a:buChar char="•"/>
             </a:pPr>
             <a:r>
-              <a:rPr lang="en-US" dirty="0"/>
+              <a:rPr lang="en-US" dirty="0">
+                <a:solidFill>
+                  <a:schemeClr val="tx1"/>
+                </a:solidFill>
+              </a:rPr>
               <a:t>Azure Student Hosting Account Set up</a:t>
             </a:r>
           </a:p>
@@ -12454,7 +13003,11 @@
               <a:buChar char="•"/>
             </a:pPr>
             <a:r>
-              <a:rPr lang="en-US" dirty="0"/>
+              <a:rPr lang="en-US" dirty="0">
+                <a:solidFill>
+                  <a:schemeClr val="tx1"/>
+                </a:solidFill>
+              </a:rPr>
               <a:t>Teams Page Progress</a:t>
             </a:r>
           </a:p>
@@ -12464,7 +13017,11 @@
               <a:buChar char="•"/>
             </a:pPr>
             <a:r>
-              <a:rPr lang="en-US" dirty="0"/>
+              <a:rPr lang="en-US" dirty="0">
+                <a:solidFill>
+                  <a:schemeClr val="tx1"/>
+                </a:solidFill>
+              </a:rPr>
               <a:t>Challenges Page Progress</a:t>
             </a:r>
           </a:p>

</xml_diff>